<commit_message>
fix(script): rewrite presentation dimensions to prevent overlap
</commit_message>
<xml_diff>
--- a/EOM_Presentation.pptx
+++ b/EOM_Presentation.pptx
@@ -2423,8 +2423,8 @@
         </p:nvSpPr>
         <p:spPr>
           <a:xfrm>
-            <a:off x="0" y="1543050"/>
-            <a:ext cx="9144000" cy="0"/>
+            <a:off x="457200" y="1828800"/>
+            <a:ext cx="8229600" cy="731520"/>
           </a:xfrm>
           <a:prstGeom prst="rect">
             <a:avLst/>
@@ -2440,14 +2440,14 @@
               <a:buNone/>
             </a:pPr>
             <a:r>
-              <a:rPr lang="en-US" sz="4400" b="1" dirty="0">
+              <a:rPr lang="en-US" sz="4800" b="1" dirty="0">
                 <a:solidFill>
                   <a:srgbClr val="FFFFFF"/>
                 </a:solidFill>
               </a:rPr>
               <a:t>EOM Presentation</a:t>
             </a:r>
-            <a:endParaRPr lang="en-US" sz="4400" dirty="0"/>
+            <a:endParaRPr lang="en-US" sz="4800" dirty="0"/>
           </a:p>
         </p:txBody>
       </p:sp>
@@ -2459,8 +2459,8 @@
         </p:nvSpPr>
         <p:spPr>
           <a:xfrm>
-            <a:off x="0" y="2314575"/>
-            <a:ext cx="9144000" cy="0"/>
+            <a:off x="457200" y="2560320"/>
+            <a:ext cx="8229600" cy="457200"/>
           </a:xfrm>
           <a:prstGeom prst="rect">
             <a:avLst/>
@@ -2469,7 +2469,7 @@
           <a:ln/>
         </p:spPr>
         <p:txBody>
-          <a:bodyPr wrap="square" rtlCol="0" anchor="ctr"/>
+          <a:bodyPr wrap="square" rtlCol="0" anchor="t"/>
           <a:lstStyle/>
           <a:p>
             <a:pPr algn="ctr" indent="0" marL="0">
@@ -2495,7 +2495,7 @@
         </p:nvSpPr>
         <p:spPr>
           <a:xfrm>
-            <a:off x="4069080" y="2828925"/>
+            <a:off x="4114800" y="3108960"/>
             <a:ext cx="914400" cy="45720"/>
           </a:xfrm>
           <a:prstGeom prst="rect">
@@ -2515,8 +2515,8 @@
         </p:nvSpPr>
         <p:spPr>
           <a:xfrm>
-            <a:off x="0" y="3343275"/>
-            <a:ext cx="9144000" cy="0"/>
+            <a:off x="457200" y="3291840"/>
+            <a:ext cx="8229600" cy="365760"/>
           </a:xfrm>
           <a:prstGeom prst="rect">
             <a:avLst/>
@@ -2525,7 +2525,7 @@
           <a:ln/>
         </p:spPr>
         <p:txBody>
-          <a:bodyPr wrap="square" rtlCol="0" anchor="ctr"/>
+          <a:bodyPr wrap="square" rtlCol="0" anchor="t"/>
           <a:lstStyle/>
           <a:p>
             <a:pPr algn="ctr" indent="0" marL="0">
@@ -2621,8 +2621,8 @@
         </p:nvSpPr>
         <p:spPr>
           <a:xfrm>
-            <a:off x="457200" y="457200"/>
-            <a:ext cx="8229600" cy="0"/>
+            <a:off x="457200" y="365760"/>
+            <a:ext cx="8229600" cy="274320"/>
           </a:xfrm>
           <a:prstGeom prst="rect">
             <a:avLst/>
@@ -2631,7 +2631,7 @@
           <a:ln/>
         </p:spPr>
         <p:txBody>
-          <a:bodyPr wrap="square" rtlCol="0" anchor="ctr"/>
+          <a:bodyPr wrap="square" rtlCol="0" anchor="t"/>
           <a:lstStyle/>
           <a:p>
             <a:pPr indent="0" marL="0">
@@ -2657,8 +2657,8 @@
         </p:nvSpPr>
         <p:spPr>
           <a:xfrm>
-            <a:off x="457200" y="731520"/>
-            <a:ext cx="8229600" cy="0"/>
+            <a:off x="457200" y="640080"/>
+            <a:ext cx="8229600" cy="548640"/>
           </a:xfrm>
           <a:prstGeom prst="rect">
             <a:avLst/>
@@ -2667,21 +2667,21 @@
           <a:ln/>
         </p:spPr>
         <p:txBody>
-          <a:bodyPr wrap="square" rtlCol="0" anchor="ctr"/>
-          <a:lstStyle/>
-          <a:p>
-            <a:pPr indent="0" marL="0">
-              <a:buNone/>
-            </a:pPr>
-            <a:r>
-              <a:rPr lang="en-US" sz="2400" b="1" dirty="0">
+          <a:bodyPr wrap="square" rtlCol="0" anchor="t"/>
+          <a:lstStyle/>
+          <a:p>
+            <a:pPr indent="0" marL="0">
+              <a:buNone/>
+            </a:pPr>
+            <a:r>
+              <a:rPr lang="en-US" sz="2800" b="1" dirty="0">
                 <a:solidFill>
                   <a:srgbClr val="FFFFFF"/>
                 </a:solidFill>
               </a:rPr>
               <a:t>Structuring the empire</a:t>
             </a:r>
-            <a:endParaRPr lang="en-US" sz="2400" dirty="0"/>
+            <a:endParaRPr lang="en-US" sz="2800" dirty="0"/>
           </a:p>
         </p:txBody>
       </p:sp>
@@ -2693,7 +2693,7 @@
         </p:nvSpPr>
         <p:spPr>
           <a:xfrm>
-            <a:off x="457200" y="1371600"/>
+            <a:off x="457200" y="1280160"/>
             <a:ext cx="8229600" cy="0"/>
           </a:xfrm>
           <a:prstGeom prst="line">
@@ -2716,8 +2716,8 @@
         </p:nvSpPr>
         <p:spPr>
           <a:xfrm>
-            <a:off x="457200" y="1645920"/>
-            <a:ext cx="8229600" cy="0"/>
+            <a:off x="457200" y="1463040"/>
+            <a:ext cx="8229600" cy="914400"/>
           </a:xfrm>
           <a:prstGeom prst="rect">
             <a:avLst/>
@@ -2726,7 +2726,7 @@
           <a:ln/>
         </p:spPr>
         <p:txBody>
-          <a:bodyPr wrap="square" rtlCol="0" anchor="ctr"/>
+          <a:bodyPr wrap="square" rtlCol="0" anchor="t"/>
           <a:lstStyle/>
           <a:p>
             <a:pPr indent="0" marL="0">
@@ -2741,7 +2741,7 @@
                   <a:srgbClr val="94A3B8"/>
                 </a:solidFill>
               </a:rPr>
-              <a:t>Historically, Toyota operated under a rigid "spoke-and-wheel" global hierarchy strictly managed from the corporate epicenter in Japan. This archaic structure proved catastrophic during the devastating 2009-2010 unintended acceleration crisis due to massive communication bottlenecks.</a:t>
+              <a:t>Historically, Toyota operated under a rigid "spoke-and-wheel" global hierarchy strictly managed from the corporate epicenter in Japan. This archaic structure proved catastrophic during the devastating 2009-2010 unintended acceleration crisis.</a:t>
             </a:r>
             <a:endParaRPr lang="en-US" sz="1400" dirty="0"/>
           </a:p>
@@ -2755,8 +2755,8 @@
         </p:nvSpPr>
         <p:spPr>
           <a:xfrm>
-            <a:off x="457200" y="2743200"/>
-            <a:ext cx="8229600" cy="0"/>
+            <a:off x="457200" y="2560320"/>
+            <a:ext cx="8229600" cy="457200"/>
           </a:xfrm>
           <a:prstGeom prst="rect">
             <a:avLst/>
@@ -2765,7 +2765,7 @@
           <a:ln/>
         </p:spPr>
         <p:txBody>
-          <a:bodyPr wrap="square" rtlCol="0" anchor="ctr"/>
+          <a:bodyPr wrap="square" rtlCol="0" anchor="t"/>
           <a:lstStyle/>
           <a:p>
             <a:pPr indent="0" marL="0">
@@ -2792,7 +2792,7 @@
         <p:spPr>
           <a:xfrm>
             <a:off x="457200" y="3108960"/>
-            <a:ext cx="8229600" cy="0"/>
+            <a:ext cx="8229600" cy="914400"/>
           </a:xfrm>
           <a:prstGeom prst="rect">
             <a:avLst/>
@@ -2801,7 +2801,7 @@
           <a:ln/>
         </p:spPr>
         <p:txBody>
-          <a:bodyPr wrap="square" rtlCol="0" anchor="ctr"/>
+          <a:bodyPr wrap="square" rtlCol="0" anchor="t"/>
           <a:lstStyle/>
           <a:p>
             <a:pPr indent="0" marL="0">
@@ -2917,8 +2917,8 @@
         </p:nvSpPr>
         <p:spPr>
           <a:xfrm>
-            <a:off x="457200" y="457200"/>
-            <a:ext cx="8229600" cy="0"/>
+            <a:off x="457200" y="365760"/>
+            <a:ext cx="8229600" cy="274320"/>
           </a:xfrm>
           <a:prstGeom prst="rect">
             <a:avLst/>
@@ -2927,7 +2927,7 @@
           <a:ln/>
         </p:spPr>
         <p:txBody>
-          <a:bodyPr wrap="square" rtlCol="0" anchor="ctr"/>
+          <a:bodyPr wrap="square" rtlCol="0" anchor="t"/>
           <a:lstStyle/>
           <a:p>
             <a:pPr indent="0" marL="0">
@@ -2953,8 +2953,8 @@
         </p:nvSpPr>
         <p:spPr>
           <a:xfrm>
-            <a:off x="457200" y="731520"/>
-            <a:ext cx="8229600" cy="0"/>
+            <a:off x="457200" y="640080"/>
+            <a:ext cx="8229600" cy="548640"/>
           </a:xfrm>
           <a:prstGeom prst="rect">
             <a:avLst/>
@@ -2963,21 +2963,21 @@
           <a:ln/>
         </p:spPr>
         <p:txBody>
-          <a:bodyPr wrap="square" rtlCol="0" anchor="ctr"/>
-          <a:lstStyle/>
-          <a:p>
-            <a:pPr indent="0" marL="0">
-              <a:buNone/>
-            </a:pPr>
-            <a:r>
-              <a:rPr lang="en-US" sz="2400" b="1" dirty="0">
+          <a:bodyPr wrap="square" rtlCol="0" anchor="t"/>
+          <a:lstStyle/>
+          <a:p>
+            <a:pPr indent="0" marL="0">
+              <a:buNone/>
+            </a:pPr>
+            <a:r>
+              <a:rPr lang="en-US" sz="2800" b="1" dirty="0">
                 <a:solidFill>
                   <a:srgbClr val="FFFFFF"/>
                 </a:solidFill>
               </a:rPr>
               <a:t>Governance &amp; restructuring</a:t>
             </a:r>
-            <a:endParaRPr lang="en-US" sz="2400" dirty="0"/>
+            <a:endParaRPr lang="en-US" sz="2800" dirty="0"/>
           </a:p>
         </p:txBody>
       </p:sp>
@@ -2989,7 +2989,7 @@
         </p:nvSpPr>
         <p:spPr>
           <a:xfrm>
-            <a:off x="457200" y="1371600"/>
+            <a:off x="457200" y="1280160"/>
             <a:ext cx="8229600" cy="0"/>
           </a:xfrm>
           <a:prstGeom prst="line">
@@ -3012,8 +3012,8 @@
         </p:nvSpPr>
         <p:spPr>
           <a:xfrm>
-            <a:off x="457200" y="1645920"/>
-            <a:ext cx="6858000" cy="0"/>
+            <a:off x="457200" y="1463040"/>
+            <a:ext cx="8229600" cy="365760"/>
           </a:xfrm>
           <a:prstGeom prst="rect">
             <a:avLst/>
@@ -3022,7 +3022,7 @@
           <a:ln/>
         </p:spPr>
         <p:txBody>
-          <a:bodyPr wrap="square" rtlCol="0" anchor="ctr"/>
+          <a:bodyPr wrap="square" rtlCol="0" anchor="t"/>
           <a:lstStyle/>
           <a:p>
             <a:pPr indent="0" marL="0">
@@ -3048,8 +3048,8 @@
         </p:nvSpPr>
         <p:spPr>
           <a:xfrm>
-            <a:off x="457200" y="2011680"/>
-            <a:ext cx="8229600" cy="0"/>
+            <a:off x="457200" y="1828800"/>
+            <a:ext cx="8229600" cy="1463040"/>
           </a:xfrm>
           <a:prstGeom prst="rect">
             <a:avLst/>
@@ -3058,7 +3058,7 @@
           <a:ln/>
         </p:spPr>
         <p:txBody>
-          <a:bodyPr wrap="square" rtlCol="0" anchor="ctr"/>
+          <a:bodyPr wrap="square" rtlCol="0" anchor="t"/>
           <a:lstStyle/>
           <a:p>
             <a:pPr indent="0" marL="0">
@@ -3138,8 +3138,8 @@
         </p:nvSpPr>
         <p:spPr>
           <a:xfrm>
-            <a:off x="457200" y="3657600"/>
-            <a:ext cx="6858000" cy="0"/>
+            <a:off x="457200" y="3474720"/>
+            <a:ext cx="8229600" cy="365760"/>
           </a:xfrm>
           <a:prstGeom prst="rect">
             <a:avLst/>
@@ -3148,7 +3148,7 @@
           <a:ln/>
         </p:spPr>
         <p:txBody>
-          <a:bodyPr wrap="square" rtlCol="0" anchor="ctr"/>
+          <a:bodyPr wrap="square" rtlCol="0" anchor="t"/>
           <a:lstStyle/>
           <a:p>
             <a:pPr indent="0" marL="0">
@@ -3174,8 +3174,8 @@
         </p:nvSpPr>
         <p:spPr>
           <a:xfrm>
-            <a:off x="457200" y="4023360"/>
-            <a:ext cx="8229600" cy="0"/>
+            <a:off x="457200" y="3840480"/>
+            <a:ext cx="8229600" cy="914400"/>
           </a:xfrm>
           <a:prstGeom prst="rect">
             <a:avLst/>
@@ -3184,7 +3184,7 @@
           <a:ln/>
         </p:spPr>
         <p:txBody>
-          <a:bodyPr wrap="square" rtlCol="0" anchor="ctr"/>
+          <a:bodyPr wrap="square" rtlCol="0" anchor="t"/>
           <a:lstStyle/>
           <a:p>
             <a:pPr indent="0" marL="0">
@@ -3216,7 +3216,7 @@
                   <a:srgbClr val="FFFFFF"/>
                 </a:solidFill>
               </a:rPr>
-              <a:t>• Kenta Kon (President &amp; CEO): Former CFO tapped to meticulously lower break-even volumes and engineer financial defenses.</a:t>
+              <a:t>• Kenta Kon (President &amp; CEO): Former CFO tapped to meticulously lower break-even volumes.</a:t>
             </a:r>
             <a:endParaRPr lang="en-US" sz="1400" dirty="0"/>
           </a:p>
@@ -3300,8 +3300,8 @@
         </p:nvSpPr>
         <p:spPr>
           <a:xfrm>
-            <a:off x="457200" y="457200"/>
-            <a:ext cx="8229600" cy="0"/>
+            <a:off x="457200" y="365760"/>
+            <a:ext cx="8229600" cy="274320"/>
           </a:xfrm>
           <a:prstGeom prst="rect">
             <a:avLst/>
@@ -3310,7 +3310,7 @@
           <a:ln/>
         </p:spPr>
         <p:txBody>
-          <a:bodyPr wrap="square" rtlCol="0" anchor="ctr"/>
+          <a:bodyPr wrap="square" rtlCol="0" anchor="t"/>
           <a:lstStyle/>
           <a:p>
             <a:pPr indent="0" marL="0">
@@ -3336,8 +3336,8 @@
         </p:nvSpPr>
         <p:spPr>
           <a:xfrm>
-            <a:off x="457200" y="731520"/>
-            <a:ext cx="8229600" cy="0"/>
+            <a:off x="457200" y="640080"/>
+            <a:ext cx="8229600" cy="548640"/>
           </a:xfrm>
           <a:prstGeom prst="rect">
             <a:avLst/>
@@ -3346,21 +3346,21 @@
           <a:ln/>
         </p:spPr>
         <p:txBody>
-          <a:bodyPr wrap="square" rtlCol="0" anchor="ctr"/>
-          <a:lstStyle/>
-          <a:p>
-            <a:pPr indent="0" marL="0">
-              <a:buNone/>
-            </a:pPr>
-            <a:r>
-              <a:rPr lang="en-US" sz="2400" b="1" dirty="0">
+          <a:bodyPr wrap="square" rtlCol="0" anchor="t"/>
+          <a:lstStyle/>
+          <a:p>
+            <a:pPr indent="0" marL="0">
+              <a:buNone/>
+            </a:pPr>
+            <a:r>
+              <a:rPr lang="en-US" sz="2800" b="1" dirty="0">
                 <a:solidFill>
                   <a:srgbClr val="FFFFFF"/>
                 </a:solidFill>
               </a:rPr>
               <a:t>The human capital asset</a:t>
             </a:r>
-            <a:endParaRPr lang="en-US" sz="2400" dirty="0"/>
+            <a:endParaRPr lang="en-US" sz="2800" dirty="0"/>
           </a:p>
         </p:txBody>
       </p:sp>
@@ -3372,7 +3372,7 @@
         </p:nvSpPr>
         <p:spPr>
           <a:xfrm>
-            <a:off x="457200" y="1371600"/>
+            <a:off x="457200" y="1280160"/>
             <a:ext cx="8229600" cy="0"/>
           </a:xfrm>
           <a:prstGeom prst="line">
@@ -3395,8 +3395,8 @@
         </p:nvSpPr>
         <p:spPr>
           <a:xfrm>
-            <a:off x="457200" y="1645920"/>
-            <a:ext cx="8229600" cy="0"/>
+            <a:off x="457200" y="1463040"/>
+            <a:ext cx="8229600" cy="1828800"/>
           </a:xfrm>
           <a:prstGeom prst="rect">
             <a:avLst/>
@@ -3405,7 +3405,7 @@
           <a:ln/>
         </p:spPr>
         <p:txBody>
-          <a:bodyPr wrap="square" rtlCol="0" anchor="ctr"/>
+          <a:bodyPr wrap="square" rtlCol="0" anchor="t"/>
           <a:lstStyle/>
           <a:p>
             <a:pPr indent="0" marL="0">
@@ -3424,28 +3424,6 @@
             </a:r>
             <a:endParaRPr lang="en-US" sz="1400" dirty="0"/>
           </a:p>
-        </p:txBody>
-      </p:sp>
-      <p:sp>
-        <p:nvSpPr>
-          <p:cNvPr id="6" name="Text 4"/>
-          <p:cNvSpPr/>
-          <p:nvPr/>
-        </p:nvSpPr>
-        <p:spPr>
-          <a:xfrm>
-            <a:off x="457200" y="2468880"/>
-            <a:ext cx="8229600" cy="0"/>
-          </a:xfrm>
-          <a:prstGeom prst="rect">
-            <a:avLst/>
-          </a:prstGeom>
-          <a:noFill/>
-          <a:ln/>
-        </p:spPr>
-        <p:txBody>
-          <a:bodyPr wrap="square" rtlCol="0" anchor="ctr"/>
-          <a:lstStyle/>
           <a:p>
             <a:pPr indent="0" marL="0">
               <a:lnSpc>
@@ -3453,6 +3431,15 @@
               </a:lnSpc>
               <a:buNone/>
             </a:pPr>
+            <a:endParaRPr lang="en-US" sz="1400" dirty="0"/>
+          </a:p>
+          <a:p>
+            <a:pPr indent="0" marL="0">
+              <a:lnSpc>
+                <a:spcPts val="2000"/>
+              </a:lnSpc>
+              <a:buNone/>
+            </a:pPr>
             <a:r>
               <a:rPr lang="en-US" sz="1400" dirty="0">
                 <a:solidFill>
@@ -3467,14 +3454,62 @@
       </p:sp>
       <p:sp>
         <p:nvSpPr>
+          <p:cNvPr id="6" name="Text 4"/>
+          <p:cNvSpPr/>
+          <p:nvPr/>
+        </p:nvSpPr>
+        <p:spPr>
+          <a:xfrm>
+            <a:off x="457200" y="3474720"/>
+            <a:ext cx="3840480" cy="1371600"/>
+          </a:xfrm>
+          <a:prstGeom prst="rect">
+            <a:avLst/>
+          </a:prstGeom>
+          <a:noFill/>
+          <a:ln/>
+        </p:spPr>
+        <p:txBody>
+          <a:bodyPr wrap="square" rtlCol="0" anchor="t"/>
+          <a:lstStyle/>
+          <a:p>
+            <a:pPr indent="0" marL="0">
+              <a:buNone/>
+            </a:pPr>
+            <a:r>
+              <a:rPr lang="en-US" sz="1400" b="1" dirty="0">
+                <a:solidFill>
+                  <a:srgbClr val="FFFFFF"/>
+                </a:solidFill>
+              </a:rPr>
+              <a:t>Blue-Collar integration
+</a:t>
+            </a:r>
+            <a:pPr indent="0" marL="0">
+              <a:buNone/>
+            </a:pPr>
+            <a:r>
+              <a:rPr lang="en-US" sz="1200" dirty="0">
+                <a:solidFill>
+                  <a:srgbClr val="94A3B8"/>
+                </a:solidFill>
+              </a:rPr>
+              <a:t>Deeply immersive OJT pairing new hires with veterans. Job rotation forces cross-training through assembly, QA, logistics.</a:t>
+            </a:r>
+            <a:endParaRPr lang="en-US" sz="1400" dirty="0"/>
+          </a:p>
+        </p:txBody>
+      </p:sp>
+      <p:sp>
+        <p:nvSpPr>
           <p:cNvPr id="7" name="Text 5"/>
           <p:cNvSpPr/>
           <p:nvPr/>
         </p:nvSpPr>
         <p:spPr>
           <a:xfrm>
-            <a:off x="457200" y="3657600"/>
-            <a:ext cx="6858000" cy="0"/>
+            <a:off x="4846320" y="3474720"/>
+            <a:ext cx="3840480" cy="1371600"/>
           </a:xfrm>
           <a:prstGeom prst="rect">
             <a:avLst/>
@@ -3483,7 +3518,7 @@
           <a:ln/>
         </p:spPr>
         <p:txBody>
-          <a:bodyPr wrap="square" rtlCol="0" anchor="ctr"/>
+          <a:bodyPr wrap="square" rtlCol="0" anchor="t"/>
           <a:lstStyle/>
           <a:p>
             <a:pPr indent="0" marL="0">
@@ -3495,123 +3530,21 @@
                   <a:srgbClr val="FFFFFF"/>
                 </a:solidFill>
               </a:rPr>
-              <a:t>Blue-Collar integration</a:t>
+              <a:t>GLOBAL 21 pipeline
+</a:t>
+            </a:r>
+            <a:pPr indent="0" marL="0">
+              <a:buNone/>
+            </a:pPr>
+            <a:r>
+              <a:rPr lang="en-US" sz="1200" dirty="0">
+                <a:solidFill>
+                  <a:srgbClr val="94A3B8"/>
+                </a:solidFill>
+              </a:rPr>
+              <a:t>Forces high-potential executives into demanding overseas assignments or MBAs to build cross-cultural operational skills.</a:t>
             </a:r>
             <a:endParaRPr lang="en-US" sz="1400" dirty="0"/>
-          </a:p>
-        </p:txBody>
-      </p:sp>
-      <p:sp>
-        <p:nvSpPr>
-          <p:cNvPr id="8" name="Text 6"/>
-          <p:cNvSpPr/>
-          <p:nvPr/>
-        </p:nvSpPr>
-        <p:spPr>
-          <a:xfrm>
-            <a:off x="457200" y="3931920"/>
-            <a:ext cx="3657600" cy="0"/>
-          </a:xfrm>
-          <a:prstGeom prst="rect">
-            <a:avLst/>
-          </a:prstGeom>
-          <a:noFill/>
-          <a:ln/>
-        </p:spPr>
-        <p:txBody>
-          <a:bodyPr wrap="square" rtlCol="0" anchor="ctr"/>
-          <a:lstStyle/>
-          <a:p>
-            <a:pPr indent="0" marL="0">
-              <a:lnSpc>
-                <a:spcPts val="1800"/>
-              </a:lnSpc>
-              <a:buNone/>
-            </a:pPr>
-            <a:r>
-              <a:rPr lang="en-US" sz="1200" dirty="0">
-                <a:solidFill>
-                  <a:srgbClr val="94A3B8"/>
-                </a:solidFill>
-              </a:rPr>
-              <a:t>Deeply immersive OJT pairing new hires with veterans. Job rotation forces cross-training through assembly, QA, logistics.</a:t>
-            </a:r>
-            <a:endParaRPr lang="en-US" sz="1200" dirty="0"/>
-          </a:p>
-        </p:txBody>
-      </p:sp>
-      <p:sp>
-        <p:nvSpPr>
-          <p:cNvPr id="9" name="Text 7"/>
-          <p:cNvSpPr/>
-          <p:nvPr/>
-        </p:nvSpPr>
-        <p:spPr>
-          <a:xfrm>
-            <a:off x="4572000" y="3657600"/>
-            <a:ext cx="6858000" cy="0"/>
-          </a:xfrm>
-          <a:prstGeom prst="rect">
-            <a:avLst/>
-          </a:prstGeom>
-          <a:noFill/>
-          <a:ln/>
-        </p:spPr>
-        <p:txBody>
-          <a:bodyPr wrap="square" rtlCol="0" anchor="ctr"/>
-          <a:lstStyle/>
-          <a:p>
-            <a:pPr indent="0" marL="0">
-              <a:buNone/>
-            </a:pPr>
-            <a:r>
-              <a:rPr lang="en-US" sz="1400" b="1" dirty="0">
-                <a:solidFill>
-                  <a:srgbClr val="FFFFFF"/>
-                </a:solidFill>
-              </a:rPr>
-              <a:t>GLOBAL 21 pipeline</a:t>
-            </a:r>
-            <a:endParaRPr lang="en-US" sz="1400" dirty="0"/>
-          </a:p>
-        </p:txBody>
-      </p:sp>
-      <p:sp>
-        <p:nvSpPr>
-          <p:cNvPr id="10" name="Text 8"/>
-          <p:cNvSpPr/>
-          <p:nvPr/>
-        </p:nvSpPr>
-        <p:spPr>
-          <a:xfrm>
-            <a:off x="4572000" y="3931920"/>
-            <a:ext cx="3657600" cy="0"/>
-          </a:xfrm>
-          <a:prstGeom prst="rect">
-            <a:avLst/>
-          </a:prstGeom>
-          <a:noFill/>
-          <a:ln/>
-        </p:spPr>
-        <p:txBody>
-          <a:bodyPr wrap="square" rtlCol="0" anchor="ctr"/>
-          <a:lstStyle/>
-          <a:p>
-            <a:pPr indent="0" marL="0">
-              <a:lnSpc>
-                <a:spcPts val="1800"/>
-              </a:lnSpc>
-              <a:buNone/>
-            </a:pPr>
-            <a:r>
-              <a:rPr lang="en-US" sz="1200" dirty="0">
-                <a:solidFill>
-                  <a:srgbClr val="94A3B8"/>
-                </a:solidFill>
-              </a:rPr>
-              <a:t>Forces high-potential executives into demanding overseas assignments or MBAs to build cross-cultural operational skills.</a:t>
-            </a:r>
-            <a:endParaRPr lang="en-US" sz="1200" dirty="0"/>
           </a:p>
         </p:txBody>
       </p:sp>
@@ -3693,8 +3626,8 @@
         </p:nvSpPr>
         <p:spPr>
           <a:xfrm>
-            <a:off x="457200" y="457200"/>
-            <a:ext cx="8229600" cy="0"/>
+            <a:off x="457200" y="365760"/>
+            <a:ext cx="8229600" cy="274320"/>
           </a:xfrm>
           <a:prstGeom prst="rect">
             <a:avLst/>
@@ -3703,7 +3636,7 @@
           <a:ln/>
         </p:spPr>
         <p:txBody>
-          <a:bodyPr wrap="square" rtlCol="0" anchor="ctr"/>
+          <a:bodyPr wrap="square" rtlCol="0" anchor="t"/>
           <a:lstStyle/>
           <a:p>
             <a:pPr indent="0" marL="0">
@@ -3729,8 +3662,8 @@
         </p:nvSpPr>
         <p:spPr>
           <a:xfrm>
-            <a:off x="457200" y="731520"/>
-            <a:ext cx="8229600" cy="0"/>
+            <a:off x="457200" y="640080"/>
+            <a:ext cx="8229600" cy="548640"/>
           </a:xfrm>
           <a:prstGeom prst="rect">
             <a:avLst/>
@@ -3739,21 +3672,21 @@
           <a:ln/>
         </p:spPr>
         <p:txBody>
-          <a:bodyPr wrap="square" rtlCol="0" anchor="ctr"/>
-          <a:lstStyle/>
-          <a:p>
-            <a:pPr indent="0" marL="0">
-              <a:buNone/>
-            </a:pPr>
-            <a:r>
-              <a:rPr lang="en-US" sz="2400" b="1" dirty="0">
+          <a:bodyPr wrap="square" rtlCol="0" anchor="t"/>
+          <a:lstStyle/>
+          <a:p>
+            <a:pPr indent="0" marL="0">
+              <a:buNone/>
+            </a:pPr>
+            <a:r>
+              <a:rPr lang="en-US" sz="2800" b="1" dirty="0">
                 <a:solidFill>
                   <a:srgbClr val="FFFFFF"/>
                 </a:solidFill>
               </a:rPr>
               <a:t>The architecture of appraisal</a:t>
             </a:r>
-            <a:endParaRPr lang="en-US" sz="2400" dirty="0"/>
+            <a:endParaRPr lang="en-US" sz="2800" dirty="0"/>
           </a:p>
         </p:txBody>
       </p:sp>
@@ -3765,7 +3698,7 @@
         </p:nvSpPr>
         <p:spPr>
           <a:xfrm>
-            <a:off x="457200" y="1371600"/>
+            <a:off x="457200" y="1280160"/>
             <a:ext cx="8229600" cy="0"/>
           </a:xfrm>
           <a:prstGeom prst="line">
@@ -3788,8 +3721,8 @@
         </p:nvSpPr>
         <p:spPr>
           <a:xfrm>
-            <a:off x="457200" y="1645920"/>
-            <a:ext cx="8229600" cy="0"/>
+            <a:off x="457200" y="1463040"/>
+            <a:ext cx="8229600" cy="365760"/>
           </a:xfrm>
           <a:prstGeom prst="rect">
             <a:avLst/>
@@ -3798,7 +3731,7 @@
           <a:ln/>
         </p:spPr>
         <p:txBody>
-          <a:bodyPr wrap="square" rtlCol="0" anchor="ctr"/>
+          <a:bodyPr wrap="square" rtlCol="0" anchor="t"/>
           <a:lstStyle/>
           <a:p>
             <a:pPr indent="0" marL="0">
@@ -3824,8 +3757,8 @@
         </p:nvSpPr>
         <p:spPr>
           <a:xfrm>
-            <a:off x="457200" y="2103120"/>
-            <a:ext cx="8229600" cy="0"/>
+            <a:off x="457200" y="1920240"/>
+            <a:ext cx="8229600" cy="2743200"/>
           </a:xfrm>
           <a:prstGeom prst="rect">
             <a:avLst/>
@@ -3834,13 +3767,10 @@
           <a:ln/>
         </p:spPr>
         <p:txBody>
-          <a:bodyPr wrap="square" rtlCol="0" anchor="ctr"/>
-          <a:lstStyle/>
-          <a:p>
-            <a:pPr indent="0" marL="0">
-              <a:lnSpc>
-                <a:spcPts val="2400"/>
-              </a:lnSpc>
+          <a:bodyPr wrap="square" rtlCol="0" anchor="t"/>
+          <a:lstStyle/>
+          <a:p>
+            <a:pPr indent="0" marL="0">
               <a:buNone/>
             </a:pPr>
             <a:r>
@@ -3852,9 +3782,6 @@
               <a:t>1. Physical skills (takt time): </a:t>
             </a:r>
             <a:pPr indent="0" marL="0">
-              <a:lnSpc>
-                <a:spcPts val="2400"/>
-              </a:lnSpc>
               <a:buNone/>
             </a:pPr>
             <a:r>
@@ -3867,9 +3794,6 @@
 </a:t>
             </a:r>
             <a:pPr indent="0" marL="0">
-              <a:lnSpc>
-                <a:spcPts val="2400"/>
-              </a:lnSpc>
               <a:buNone/>
             </a:pPr>
             <a:r>
@@ -3881,9 +3805,6 @@
               <a:t>2. Quality maintenance: </a:t>
             </a:r>
             <a:pPr indent="0" marL="0">
-              <a:lnSpc>
-                <a:spcPts val="2400"/>
-              </a:lnSpc>
               <a:buNone/>
             </a:pPr>
             <a:r>
@@ -3896,9 +3817,6 @@
 </a:t>
             </a:r>
             <a:pPr indent="0" marL="0">
-              <a:lnSpc>
-                <a:spcPts val="2400"/>
-              </a:lnSpc>
               <a:buNone/>
             </a:pPr>
             <a:r>
@@ -3910,9 +3828,6 @@
               <a:t>3. Kaizen participation: </a:t>
             </a:r>
             <a:pPr indent="0" marL="0">
-              <a:lnSpc>
-                <a:spcPts val="2400"/>
-              </a:lnSpc>
               <a:buNone/>
             </a:pPr>
             <a:r>
@@ -3925,9 +3840,6 @@
 </a:t>
             </a:r>
             <a:pPr indent="0" marL="0">
-              <a:lnSpc>
-                <a:spcPts val="2400"/>
-              </a:lnSpc>
               <a:buNone/>
             </a:pPr>
             <a:r>
@@ -3939,9 +3851,6 @@
               <a:t>4. Big picture view: </a:t>
             </a:r>
             <a:pPr indent="0" marL="0">
-              <a:lnSpc>
-                <a:spcPts val="2400"/>
-              </a:lnSpc>
               <a:buNone/>
             </a:pPr>
             <a:r>
@@ -3954,9 +3863,6 @@
 </a:t>
             </a:r>
             <a:pPr indent="0" marL="0">
-              <a:lnSpc>
-                <a:spcPts val="2400"/>
-              </a:lnSpc>
               <a:buNone/>
             </a:pPr>
             <a:r>
@@ -3968,9 +3874,6 @@
               <a:t>5. Problem solving: </a:t>
             </a:r>
             <a:pPr indent="0" marL="0">
-              <a:lnSpc>
-                <a:spcPts val="2400"/>
-              </a:lnSpc>
               <a:buNone/>
             </a:pPr>
             <a:r>
@@ -4063,8 +3966,8 @@
         </p:nvSpPr>
         <p:spPr>
           <a:xfrm>
-            <a:off x="457200" y="457200"/>
-            <a:ext cx="8229600" cy="0"/>
+            <a:off x="457200" y="365760"/>
+            <a:ext cx="8229600" cy="274320"/>
           </a:xfrm>
           <a:prstGeom prst="rect">
             <a:avLst/>
@@ -4073,7 +3976,7 @@
           <a:ln/>
         </p:spPr>
         <p:txBody>
-          <a:bodyPr wrap="square" rtlCol="0" anchor="ctr"/>
+          <a:bodyPr wrap="square" rtlCol="0" anchor="t"/>
           <a:lstStyle/>
           <a:p>
             <a:pPr indent="0" marL="0">
@@ -4099,8 +4002,8 @@
         </p:nvSpPr>
         <p:spPr>
           <a:xfrm>
-            <a:off x="457200" y="731520"/>
-            <a:ext cx="8229600" cy="0"/>
+            <a:off x="457200" y="640080"/>
+            <a:ext cx="8229600" cy="548640"/>
           </a:xfrm>
           <a:prstGeom prst="rect">
             <a:avLst/>
@@ -4109,21 +4012,21 @@
           <a:ln/>
         </p:spPr>
         <p:txBody>
-          <a:bodyPr wrap="square" rtlCol="0" anchor="ctr"/>
-          <a:lstStyle/>
-          <a:p>
-            <a:pPr indent="0" marL="0">
-              <a:buNone/>
-            </a:pPr>
-            <a:r>
-              <a:rPr lang="en-US" sz="2400" b="1" dirty="0">
+          <a:bodyPr wrap="square" rtlCol="0" anchor="t"/>
+          <a:lstStyle/>
+          <a:p>
+            <a:pPr indent="0" marL="0">
+              <a:buNone/>
+            </a:pPr>
+            <a:r>
+              <a:rPr lang="en-US" sz="2800" b="1" dirty="0">
                 <a:solidFill>
                   <a:srgbClr val="FFFFFF"/>
                 </a:solidFill>
               </a:rPr>
               <a:t>Facilitating horizontal alignment</a:t>
             </a:r>
-            <a:endParaRPr lang="en-US" sz="2400" dirty="0"/>
+            <a:endParaRPr lang="en-US" sz="2800" dirty="0"/>
           </a:p>
         </p:txBody>
       </p:sp>
@@ -4135,7 +4038,7 @@
         </p:nvSpPr>
         <p:spPr>
           <a:xfrm>
-            <a:off x="457200" y="1371600"/>
+            <a:off x="457200" y="1280160"/>
             <a:ext cx="8229600" cy="0"/>
           </a:xfrm>
           <a:prstGeom prst="line">
@@ -4158,8 +4061,8 @@
         </p:nvSpPr>
         <p:spPr>
           <a:xfrm>
-            <a:off x="457200" y="1645920"/>
-            <a:ext cx="8229600" cy="0"/>
+            <a:off x="457200" y="1463040"/>
+            <a:ext cx="8229600" cy="1097280"/>
           </a:xfrm>
           <a:prstGeom prst="rect">
             <a:avLst/>
@@ -4168,7 +4071,7 @@
           <a:ln/>
         </p:spPr>
         <p:txBody>
-          <a:bodyPr wrap="square" rtlCol="0" anchor="ctr"/>
+          <a:bodyPr wrap="square" rtlCol="0" anchor="t"/>
           <a:lstStyle/>
           <a:p>
             <a:pPr indent="0" marL="0">
@@ -4197,8 +4100,8 @@
         </p:nvSpPr>
         <p:spPr>
           <a:xfrm>
-            <a:off x="457200" y="2926080"/>
-            <a:ext cx="6858000" cy="0"/>
+            <a:off x="457200" y="2743200"/>
+            <a:ext cx="8229600" cy="1097280"/>
           </a:xfrm>
           <a:prstGeom prst="rect">
             <a:avLst/>
@@ -4207,7 +4110,7 @@
           <a:ln/>
         </p:spPr>
         <p:txBody>
-          <a:bodyPr wrap="square" rtlCol="0" anchor="ctr"/>
+          <a:bodyPr wrap="square" rtlCol="0" anchor="t"/>
           <a:lstStyle/>
           <a:p>
             <a:pPr indent="0" marL="0">
@@ -4219,7 +4122,19 @@
                   <a:srgbClr val="DC2626"/>
                 </a:solidFill>
               </a:rPr>
-              <a:t>The obeya system (Big Room)</a:t>
+              <a:t>The obeya system (Big Room)
+</a:t>
+            </a:r>
+            <a:pPr indent="0" marL="0">
+              <a:buNone/>
+            </a:pPr>
+            <a:r>
+              <a:rPr lang="en-US" sz="1400" dirty="0">
+                <a:solidFill>
+                  <a:srgbClr val="FFFFFF"/>
+                </a:solidFill>
+              </a:rPr>
+              <a:t>Cross-functional engineers from conflicting departments converge in a highly visual workspace to practice genchi genbutsu. A3 problem solving documents plaster walls to demolish email chains and force face-to-face decisions.</a:t>
             </a:r>
             <a:endParaRPr lang="en-US" sz="1600" dirty="0"/>
           </a:p>
@@ -4233,8 +4148,8 @@
         </p:nvSpPr>
         <p:spPr>
           <a:xfrm>
-            <a:off x="457200" y="3291840"/>
-            <a:ext cx="8229600" cy="0"/>
+            <a:off x="457200" y="4023360"/>
+            <a:ext cx="8229600" cy="914400"/>
           </a:xfrm>
           <a:prstGeom prst="rect">
             <a:avLst/>
@@ -4243,13 +4158,22 @@
           <a:ln/>
         </p:spPr>
         <p:txBody>
-          <a:bodyPr wrap="square" rtlCol="0" anchor="ctr"/>
-          <a:lstStyle/>
-          <a:p>
-            <a:pPr indent="0" marL="0">
-              <a:lnSpc>
-                <a:spcPts val="1800"/>
-              </a:lnSpc>
+          <a:bodyPr wrap="square" rtlCol="0" anchor="t"/>
+          <a:lstStyle/>
+          <a:p>
+            <a:pPr indent="0" marL="0">
+              <a:buNone/>
+            </a:pPr>
+            <a:r>
+              <a:rPr lang="en-US" sz="1600" b="1" dirty="0">
+                <a:solidFill>
+                  <a:srgbClr val="DC2626"/>
+                </a:solidFill>
+              </a:rPr>
+              <a:t>Toyota times (2020)
+</a:t>
+            </a:r>
+            <a:pPr indent="0" marL="0">
               <a:buNone/>
             </a:pPr>
             <a:r>
@@ -4258,81 +4182,9 @@
                   <a:srgbClr val="FFFFFF"/>
                 </a:solidFill>
               </a:rPr>
-              <a:t>Cross-functional engineers from conflicting departments converge in a highly visual workspace to practice genchi genbutsu. A3 problem solving documents plaster walls to demolish email chains and force face-to-face decisions.</a:t>
-            </a:r>
-            <a:endParaRPr lang="en-US" sz="1400" dirty="0"/>
-          </a:p>
-        </p:txBody>
-      </p:sp>
-      <p:sp>
-        <p:nvSpPr>
-          <p:cNvPr id="8" name="Text 6"/>
-          <p:cNvSpPr/>
-          <p:nvPr/>
-        </p:nvSpPr>
-        <p:spPr>
-          <a:xfrm>
-            <a:off x="457200" y="4114800"/>
-            <a:ext cx="6858000" cy="0"/>
-          </a:xfrm>
-          <a:prstGeom prst="rect">
-            <a:avLst/>
-          </a:prstGeom>
-          <a:noFill/>
-          <a:ln/>
-        </p:spPr>
-        <p:txBody>
-          <a:bodyPr wrap="square" rtlCol="0" anchor="ctr"/>
-          <a:lstStyle/>
-          <a:p>
-            <a:pPr indent="0" marL="0">
-              <a:buNone/>
-            </a:pPr>
-            <a:r>
-              <a:rPr lang="en-US" sz="1600" b="1" dirty="0">
-                <a:solidFill>
-                  <a:srgbClr val="DC2626"/>
-                </a:solidFill>
-              </a:rPr>
-              <a:t>Toyota times (2020)</a:t>
+              <a:t>Open-media channel projecting top management's unfiltered thoughts directly to the public &amp; workforce.</a:t>
             </a:r>
             <a:endParaRPr lang="en-US" sz="1600" dirty="0"/>
-          </a:p>
-        </p:txBody>
-      </p:sp>
-      <p:sp>
-        <p:nvSpPr>
-          <p:cNvPr id="9" name="Text 7"/>
-          <p:cNvSpPr/>
-          <p:nvPr/>
-        </p:nvSpPr>
-        <p:spPr>
-          <a:xfrm>
-            <a:off x="457200" y="4389120"/>
-            <a:ext cx="8229600" cy="0"/>
-          </a:xfrm>
-          <a:prstGeom prst="rect">
-            <a:avLst/>
-          </a:prstGeom>
-          <a:noFill/>
-          <a:ln/>
-        </p:spPr>
-        <p:txBody>
-          <a:bodyPr wrap="square" rtlCol="0" anchor="ctr"/>
-          <a:lstStyle/>
-          <a:p>
-            <a:pPr indent="0" marL="0">
-              <a:buNone/>
-            </a:pPr>
-            <a:r>
-              <a:rPr lang="en-US" sz="1400" dirty="0">
-                <a:solidFill>
-                  <a:srgbClr val="FFFFFF"/>
-                </a:solidFill>
-              </a:rPr>
-              <a:t>Open-media channel projecting top management's unfiltered thoughts directly to the public &amp; workforce.</a:t>
-            </a:r>
-            <a:endParaRPr lang="en-US" sz="1400" dirty="0"/>
           </a:p>
         </p:txBody>
       </p:sp>
@@ -4414,8 +4266,8 @@
         </p:nvSpPr>
         <p:spPr>
           <a:xfrm>
-            <a:off x="457200" y="457200"/>
-            <a:ext cx="8229600" cy="0"/>
+            <a:off x="457200" y="365760"/>
+            <a:ext cx="8229600" cy="274320"/>
           </a:xfrm>
           <a:prstGeom prst="rect">
             <a:avLst/>
@@ -4424,7 +4276,7 @@
           <a:ln/>
         </p:spPr>
         <p:txBody>
-          <a:bodyPr wrap="square" rtlCol="0" anchor="ctr"/>
+          <a:bodyPr wrap="square" rtlCol="0" anchor="t"/>
           <a:lstStyle/>
           <a:p>
             <a:pPr indent="0" marL="0">
@@ -4450,8 +4302,8 @@
         </p:nvSpPr>
         <p:spPr>
           <a:xfrm>
-            <a:off x="457200" y="731520"/>
-            <a:ext cx="8229600" cy="0"/>
+            <a:off x="457200" y="640080"/>
+            <a:ext cx="8229600" cy="548640"/>
           </a:xfrm>
           <a:prstGeom prst="rect">
             <a:avLst/>
@@ -4460,21 +4312,21 @@
           <a:ln/>
         </p:spPr>
         <p:txBody>
-          <a:bodyPr wrap="square" rtlCol="0" anchor="ctr"/>
-          <a:lstStyle/>
-          <a:p>
-            <a:pPr indent="0" marL="0">
-              <a:buNone/>
-            </a:pPr>
-            <a:r>
-              <a:rPr lang="en-US" sz="2400" b="1" dirty="0">
+          <a:bodyPr wrap="square" rtlCol="0" anchor="t"/>
+          <a:lstStyle/>
+          <a:p>
+            <a:pPr indent="0" marL="0">
+              <a:buNone/>
+            </a:pPr>
+            <a:r>
+              <a:rPr lang="en-US" sz="2800" b="1" dirty="0">
                 <a:solidFill>
                   <a:srgbClr val="FFFFFF"/>
                 </a:solidFill>
               </a:rPr>
               <a:t>Democratizing innovation</a:t>
             </a:r>
-            <a:endParaRPr lang="en-US" sz="2400" dirty="0"/>
+            <a:endParaRPr lang="en-US" sz="2800" dirty="0"/>
           </a:p>
         </p:txBody>
       </p:sp>
@@ -4486,7 +4338,7 @@
         </p:nvSpPr>
         <p:spPr>
           <a:xfrm>
-            <a:off x="457200" y="1371600"/>
+            <a:off x="457200" y="1280160"/>
             <a:ext cx="8229600" cy="0"/>
           </a:xfrm>
           <a:prstGeom prst="line">
@@ -4509,8 +4361,8 @@
         </p:nvSpPr>
         <p:spPr>
           <a:xfrm>
-            <a:off x="457200" y="1645920"/>
-            <a:ext cx="8229600" cy="0"/>
+            <a:off x="457200" y="1463040"/>
+            <a:ext cx="8229600" cy="731520"/>
           </a:xfrm>
           <a:prstGeom prst="rect">
             <a:avLst/>
@@ -4519,7 +4371,7 @@
           <a:ln/>
         </p:spPr>
         <p:txBody>
-          <a:bodyPr wrap="square" rtlCol="0" anchor="ctr"/>
+          <a:bodyPr wrap="square" rtlCol="0" anchor="t"/>
           <a:lstStyle/>
           <a:p>
             <a:pPr indent="0" marL="0">
@@ -4548,8 +4400,8 @@
         </p:nvSpPr>
         <p:spPr>
           <a:xfrm>
-            <a:off x="457200" y="2560320"/>
-            <a:ext cx="6858000" cy="0"/>
+            <a:off x="457200" y="2377440"/>
+            <a:ext cx="8229600" cy="365760"/>
           </a:xfrm>
           <a:prstGeom prst="rect">
             <a:avLst/>
@@ -4558,7 +4410,7 @@
           <a:ln/>
         </p:spPr>
         <p:txBody>
-          <a:bodyPr wrap="square" rtlCol="0" anchor="ctr"/>
+          <a:bodyPr wrap="square" rtlCol="0" anchor="t"/>
           <a:lstStyle/>
           <a:p>
             <a:pPr indent="0" marL="0">
@@ -4584,8 +4436,8 @@
         </p:nvSpPr>
         <p:spPr>
           <a:xfrm>
-            <a:off x="457200" y="2926080"/>
-            <a:ext cx="8229600" cy="0"/>
+            <a:off x="457200" y="2743200"/>
+            <a:ext cx="8229600" cy="1097280"/>
           </a:xfrm>
           <a:prstGeom prst="rect">
             <a:avLst/>
@@ -4594,7 +4446,7 @@
           <a:ln/>
         </p:spPr>
         <p:txBody>
-          <a:bodyPr wrap="square" rtlCol="0" anchor="ctr"/>
+          <a:bodyPr wrap="square" rtlCol="0" anchor="t"/>
           <a:lstStyle/>
           <a:p>
             <a:pPr indent="0" marL="0">
@@ -4674,8 +4526,8 @@
         </p:nvSpPr>
         <p:spPr>
           <a:xfrm>
-            <a:off x="457200" y="4114800"/>
-            <a:ext cx="6858000" cy="0"/>
+            <a:off x="457200" y="4023360"/>
+            <a:ext cx="8229600" cy="365760"/>
           </a:xfrm>
           <a:prstGeom prst="rect">
             <a:avLst/>
@@ -4684,7 +4536,7 @@
           <a:ln/>
         </p:spPr>
         <p:txBody>
-          <a:bodyPr wrap="square" rtlCol="0" anchor="ctr"/>
+          <a:bodyPr wrap="square" rtlCol="0" anchor="t"/>
           <a:lstStyle/>
           <a:p>
             <a:pPr indent="0" marL="0">
@@ -4711,7 +4563,7 @@
         <p:spPr>
           <a:xfrm>
             <a:off x="457200" y="4389120"/>
-            <a:ext cx="8229600" cy="0"/>
+            <a:ext cx="8229600" cy="731520"/>
           </a:xfrm>
           <a:prstGeom prst="rect">
             <a:avLst/>
@@ -4720,7 +4572,7 @@
           <a:ln/>
         </p:spPr>
         <p:txBody>
-          <a:bodyPr wrap="square" rtlCol="0" anchor="ctr"/>
+          <a:bodyPr wrap="square" rtlCol="0" anchor="t"/>
           <a:lstStyle/>
           <a:p>
             <a:pPr indent="0" marL="0">
@@ -4819,8 +4671,8 @@
         </p:nvSpPr>
         <p:spPr>
           <a:xfrm>
-            <a:off x="457200" y="457200"/>
-            <a:ext cx="8229600" cy="0"/>
+            <a:off x="457200" y="365760"/>
+            <a:ext cx="8229600" cy="274320"/>
           </a:xfrm>
           <a:prstGeom prst="rect">
             <a:avLst/>
@@ -4829,7 +4681,7 @@
           <a:ln/>
         </p:spPr>
         <p:txBody>
-          <a:bodyPr wrap="square" rtlCol="0" anchor="ctr"/>
+          <a:bodyPr wrap="square" rtlCol="0" anchor="t"/>
           <a:lstStyle/>
           <a:p>
             <a:pPr indent="0" marL="0">
@@ -4855,8 +4707,8 @@
         </p:nvSpPr>
         <p:spPr>
           <a:xfrm>
-            <a:off x="457200" y="731520"/>
-            <a:ext cx="8229600" cy="0"/>
+            <a:off x="457200" y="640080"/>
+            <a:ext cx="8229600" cy="548640"/>
           </a:xfrm>
           <a:prstGeom prst="rect">
             <a:avLst/>
@@ -4865,21 +4717,21 @@
           <a:ln/>
         </p:spPr>
         <p:txBody>
-          <a:bodyPr wrap="square" rtlCol="0" anchor="ctr"/>
-          <a:lstStyle/>
-          <a:p>
-            <a:pPr indent="0" marL="0">
-              <a:buNone/>
-            </a:pPr>
-            <a:r>
-              <a:rPr lang="en-US" sz="2400" b="1" dirty="0">
+          <a:bodyPr wrap="square" rtlCol="0" anchor="t"/>
+          <a:lstStyle/>
+          <a:p>
+            <a:pPr indent="0" marL="0">
+              <a:buNone/>
+            </a:pPr>
+            <a:r>
+              <a:rPr lang="en-US" sz="2800" b="1" dirty="0">
                 <a:solidFill>
                   <a:srgbClr val="FFFFFF"/>
                 </a:solidFill>
               </a:rPr>
               <a:t>Algorithmic control &amp; oversight</a:t>
             </a:r>
-            <a:endParaRPr lang="en-US" sz="2400" dirty="0"/>
+            <a:endParaRPr lang="en-US" sz="2800" dirty="0"/>
           </a:p>
         </p:txBody>
       </p:sp>
@@ -4891,7 +4743,7 @@
         </p:nvSpPr>
         <p:spPr>
           <a:xfrm>
-            <a:off x="457200" y="1371600"/>
+            <a:off x="457200" y="1280160"/>
             <a:ext cx="8229600" cy="0"/>
           </a:xfrm>
           <a:prstGeom prst="line">
@@ -4914,8 +4766,8 @@
         </p:nvSpPr>
         <p:spPr>
           <a:xfrm>
-            <a:off x="457200" y="1645920"/>
-            <a:ext cx="6858000" cy="0"/>
+            <a:off x="457200" y="1463040"/>
+            <a:ext cx="8229600" cy="365760"/>
           </a:xfrm>
           <a:prstGeom prst="rect">
             <a:avLst/>
@@ -4924,7 +4776,7 @@
           <a:ln/>
         </p:spPr>
         <p:txBody>
-          <a:bodyPr wrap="square" rtlCol="0" anchor="ctr"/>
+          <a:bodyPr wrap="square" rtlCol="0" anchor="t"/>
           <a:lstStyle/>
           <a:p>
             <a:pPr indent="0" marL="0">
@@ -4950,8 +4802,8 @@
         </p:nvSpPr>
         <p:spPr>
           <a:xfrm>
-            <a:off x="457200" y="2011680"/>
-            <a:ext cx="8229600" cy="0"/>
+            <a:off x="457200" y="1828800"/>
+            <a:ext cx="8229600" cy="1097280"/>
           </a:xfrm>
           <a:prstGeom prst="rect">
             <a:avLst/>
@@ -4960,7 +4812,7 @@
           <a:ln/>
         </p:spPr>
         <p:txBody>
-          <a:bodyPr wrap="square" rtlCol="0" anchor="ctr"/>
+          <a:bodyPr wrap="square" rtlCol="0" anchor="t"/>
           <a:lstStyle/>
           <a:p>
             <a:pPr indent="0" marL="0">
@@ -4997,15 +4849,15 @@
         </p:nvGraphicFramePr>
         <p:xfrm>
           <a:off x="457200" y="3108960"/>
-          <a:ext cx="6858000" cy="914400"/>
+          <a:ext cx="8229600" cy="914400"/>
         </p:xfrm>
         <a:graphic>
           <a:graphicData uri="http://schemas.openxmlformats.org/drawingml/2006/table">
             <a:tbl>
               <a:tblPr/>
               <a:tblGrid>
-                <a:gridCol w="3657600"/>
-                <a:gridCol w="3657600"/>
+                <a:gridCol w="4114800"/>
+                <a:gridCol w="4114800"/>
               </a:tblGrid>
               <a:tr h="365760">
                 <a:tc>
@@ -5709,8 +5561,8 @@
         </p:nvSpPr>
         <p:spPr>
           <a:xfrm>
-            <a:off x="457200" y="457200"/>
-            <a:ext cx="8229600" cy="0"/>
+            <a:off x="457200" y="365760"/>
+            <a:ext cx="8229600" cy="274320"/>
           </a:xfrm>
           <a:prstGeom prst="rect">
             <a:avLst/>
@@ -5719,7 +5571,7 @@
           <a:ln/>
         </p:spPr>
         <p:txBody>
-          <a:bodyPr wrap="square" rtlCol="0" anchor="ctr"/>
+          <a:bodyPr wrap="square" rtlCol="0" anchor="t"/>
           <a:lstStyle/>
           <a:p>
             <a:pPr indent="0" marL="0">
@@ -5745,8 +5597,8 @@
         </p:nvSpPr>
         <p:spPr>
           <a:xfrm>
-            <a:off x="457200" y="731520"/>
-            <a:ext cx="8229600" cy="0"/>
+            <a:off x="457200" y="640080"/>
+            <a:ext cx="8229600" cy="548640"/>
           </a:xfrm>
           <a:prstGeom prst="rect">
             <a:avLst/>
@@ -5755,21 +5607,21 @@
           <a:ln/>
         </p:spPr>
         <p:txBody>
-          <a:bodyPr wrap="square" rtlCol="0" anchor="ctr"/>
-          <a:lstStyle/>
-          <a:p>
-            <a:pPr indent="0" marL="0">
-              <a:buNone/>
-            </a:pPr>
-            <a:r>
-              <a:rPr lang="en-US" sz="2400" b="1" dirty="0">
+          <a:bodyPr wrap="square" rtlCol="0" anchor="t"/>
+          <a:lstStyle/>
+          <a:p>
+            <a:pPr indent="0" marL="0">
+              <a:buNone/>
+            </a:pPr>
+            <a:r>
+              <a:rPr lang="en-US" sz="2800" b="1" dirty="0">
                 <a:solidFill>
                   <a:srgbClr val="FFFFFF"/>
                 </a:solidFill>
               </a:rPr>
               <a:t>Compliance &amp; environmental control</a:t>
             </a:r>
-            <a:endParaRPr lang="en-US" sz="2400" dirty="0"/>
+            <a:endParaRPr lang="en-US" sz="2800" dirty="0"/>
           </a:p>
         </p:txBody>
       </p:sp>
@@ -5781,7 +5633,7 @@
         </p:nvSpPr>
         <p:spPr>
           <a:xfrm>
-            <a:off x="457200" y="1371600"/>
+            <a:off x="457200" y="1280160"/>
             <a:ext cx="8229600" cy="0"/>
           </a:xfrm>
           <a:prstGeom prst="line">
@@ -5804,8 +5656,8 @@
         </p:nvSpPr>
         <p:spPr>
           <a:xfrm>
-            <a:off x="457200" y="1645920"/>
-            <a:ext cx="6858000" cy="0"/>
+            <a:off x="457200" y="1463040"/>
+            <a:ext cx="8229600" cy="365760"/>
           </a:xfrm>
           <a:prstGeom prst="rect">
             <a:avLst/>
@@ -5814,7 +5666,7 @@
           <a:ln/>
         </p:spPr>
         <p:txBody>
-          <a:bodyPr wrap="square" rtlCol="0" anchor="ctr"/>
+          <a:bodyPr wrap="square" rtlCol="0" anchor="t"/>
           <a:lstStyle/>
           <a:p>
             <a:pPr indent="0" marL="0">
@@ -5840,8 +5692,8 @@
         </p:nvSpPr>
         <p:spPr>
           <a:xfrm>
-            <a:off x="457200" y="2011680"/>
-            <a:ext cx="8229600" cy="0"/>
+            <a:off x="457200" y="1828800"/>
+            <a:ext cx="8229600" cy="1097280"/>
           </a:xfrm>
           <a:prstGeom prst="rect">
             <a:avLst/>
@@ -5850,7 +5702,7 @@
           <a:ln/>
         </p:spPr>
         <p:txBody>
-          <a:bodyPr wrap="square" rtlCol="0" anchor="ctr"/>
+          <a:bodyPr wrap="square" rtlCol="0" anchor="t"/>
           <a:lstStyle/>
           <a:p>
             <a:pPr indent="0" marL="0">
@@ -5879,8 +5731,8 @@
         </p:nvSpPr>
         <p:spPr>
           <a:xfrm>
-            <a:off x="457200" y="3200400"/>
-            <a:ext cx="6858000" cy="0"/>
+            <a:off x="457200" y="3108960"/>
+            <a:ext cx="8229600" cy="365760"/>
           </a:xfrm>
           <a:prstGeom prst="rect">
             <a:avLst/>
@@ -5889,7 +5741,7 @@
           <a:ln/>
         </p:spPr>
         <p:txBody>
-          <a:bodyPr wrap="square" rtlCol="0" anchor="ctr"/>
+          <a:bodyPr wrap="square" rtlCol="0" anchor="t"/>
           <a:lstStyle/>
           <a:p>
             <a:pPr indent="0" marL="0">
@@ -5915,8 +5767,8 @@
         </p:nvSpPr>
         <p:spPr>
           <a:xfrm>
-            <a:off x="457200" y="3566160"/>
-            <a:ext cx="8229600" cy="0"/>
+            <a:off x="457200" y="3474720"/>
+            <a:ext cx="8229600" cy="1371600"/>
           </a:xfrm>
           <a:prstGeom prst="rect">
             <a:avLst/>
@@ -5925,7 +5777,7 @@
           <a:ln/>
         </p:spPr>
         <p:txBody>
-          <a:bodyPr wrap="square" rtlCol="0" anchor="ctr"/>
+          <a:bodyPr wrap="square" rtlCol="0" anchor="t"/>
           <a:lstStyle/>
           <a:p>
             <a:pPr indent="0" marL="0">
@@ -6041,8 +5893,8 @@
         </p:nvSpPr>
         <p:spPr>
           <a:xfrm>
-            <a:off x="457200" y="457200"/>
-            <a:ext cx="8229600" cy="0"/>
+            <a:off x="457200" y="365760"/>
+            <a:ext cx="8229600" cy="274320"/>
           </a:xfrm>
           <a:prstGeom prst="rect">
             <a:avLst/>
@@ -6051,7 +5903,7 @@
           <a:ln/>
         </p:spPr>
         <p:txBody>
-          <a:bodyPr wrap="square" rtlCol="0" anchor="ctr"/>
+          <a:bodyPr wrap="square" rtlCol="0" anchor="t"/>
           <a:lstStyle/>
           <a:p>
             <a:pPr indent="0" marL="0">
@@ -6077,8 +5929,8 @@
         </p:nvSpPr>
         <p:spPr>
           <a:xfrm>
-            <a:off x="457200" y="731520"/>
-            <a:ext cx="8229600" cy="0"/>
+            <a:off x="457200" y="640080"/>
+            <a:ext cx="8229600" cy="548640"/>
           </a:xfrm>
           <a:prstGeom prst="rect">
             <a:avLst/>
@@ -6087,21 +5939,21 @@
           <a:ln/>
         </p:spPr>
         <p:txBody>
-          <a:bodyPr wrap="square" rtlCol="0" anchor="ctr"/>
-          <a:lstStyle/>
-          <a:p>
-            <a:pPr indent="0" marL="0">
-              <a:buNone/>
-            </a:pPr>
-            <a:r>
-              <a:rPr lang="en-US" sz="2400" b="1" dirty="0">
+          <a:bodyPr wrap="square" rtlCol="0" anchor="t"/>
+          <a:lstStyle/>
+          <a:p>
+            <a:pPr indent="0" marL="0">
+              <a:buNone/>
+            </a:pPr>
+            <a:r>
+              <a:rPr lang="en-US" sz="2800" b="1" dirty="0">
                 <a:solidFill>
                   <a:srgbClr val="FFFFFF"/>
                 </a:solidFill>
               </a:rPr>
               <a:t>The metamorphosis</a:t>
             </a:r>
-            <a:endParaRPr lang="en-US" sz="2400" dirty="0"/>
+            <a:endParaRPr lang="en-US" sz="2800" dirty="0"/>
           </a:p>
         </p:txBody>
       </p:sp>
@@ -6113,7 +5965,7 @@
         </p:nvSpPr>
         <p:spPr>
           <a:xfrm>
-            <a:off x="457200" y="1371600"/>
+            <a:off x="457200" y="1280160"/>
             <a:ext cx="8229600" cy="0"/>
           </a:xfrm>
           <a:prstGeom prst="line">
@@ -6136,8 +5988,8 @@
         </p:nvSpPr>
         <p:spPr>
           <a:xfrm>
-            <a:off x="457200" y="1645920"/>
-            <a:ext cx="8229600" cy="0"/>
+            <a:off x="457200" y="1463040"/>
+            <a:ext cx="8229600" cy="2286000"/>
           </a:xfrm>
           <a:prstGeom prst="rect">
             <a:avLst/>
@@ -6146,7 +5998,7 @@
           <a:ln/>
         </p:spPr>
         <p:txBody>
-          <a:bodyPr wrap="square" rtlCol="0" anchor="ctr"/>
+          <a:bodyPr wrap="square" rtlCol="0" anchor="t"/>
           <a:lstStyle/>
           <a:p>
             <a:pPr indent="0" marL="0">
@@ -6165,28 +6017,6 @@
             </a:r>
             <a:endParaRPr lang="en-US" sz="1400" dirty="0"/>
           </a:p>
-        </p:txBody>
-      </p:sp>
-      <p:sp>
-        <p:nvSpPr>
-          <p:cNvPr id="6" name="Text 4"/>
-          <p:cNvSpPr/>
-          <p:nvPr/>
-        </p:nvSpPr>
-        <p:spPr>
-          <a:xfrm>
-            <a:off x="457200" y="2926080"/>
-            <a:ext cx="8229600" cy="0"/>
-          </a:xfrm>
-          <a:prstGeom prst="rect">
-            <a:avLst/>
-          </a:prstGeom>
-          <a:noFill/>
-          <a:ln/>
-        </p:spPr>
-        <p:txBody>
-          <a:bodyPr wrap="square" rtlCol="0" anchor="ctr"/>
-          <a:lstStyle/>
           <a:p>
             <a:pPr indent="0" marL="0">
               <a:lnSpc>
@@ -6194,6 +6024,15 @@
               </a:lnSpc>
               <a:buNone/>
             </a:pPr>
+            <a:endParaRPr lang="en-US" sz="1400" dirty="0"/>
+          </a:p>
+          <a:p>
+            <a:pPr indent="0" marL="0">
+              <a:lnSpc>
+                <a:spcPts val="2000"/>
+              </a:lnSpc>
+              <a:buNone/>
+            </a:pPr>
             <a:r>
               <a:rPr lang="en-US" sz="1400" dirty="0">
                 <a:solidFill>
@@ -6208,14 +6047,14 @@
       </p:sp>
       <p:sp>
         <p:nvSpPr>
-          <p:cNvPr id="7" name="Shape 5"/>
-          <p:cNvSpPr/>
-          <p:nvPr/>
-        </p:nvSpPr>
-        <p:spPr>
-          <a:xfrm>
-            <a:off x="457200" y="4114800"/>
-            <a:ext cx="8229600" cy="548640"/>
+          <p:cNvPr id="6" name="Shape 4"/>
+          <p:cNvSpPr/>
+          <p:nvPr/>
+        </p:nvSpPr>
+        <p:spPr>
+          <a:xfrm>
+            <a:off x="457200" y="4023360"/>
+            <a:ext cx="8229600" cy="731520"/>
           </a:xfrm>
           <a:prstGeom prst="rect">
             <a:avLst/>
@@ -6228,14 +6067,14 @@
       </p:sp>
       <p:sp>
         <p:nvSpPr>
-          <p:cNvPr id="8" name="Shape 6"/>
-          <p:cNvSpPr/>
-          <p:nvPr/>
-        </p:nvSpPr>
-        <p:spPr>
-          <a:xfrm>
-            <a:off x="457200" y="4114800"/>
-            <a:ext cx="45720" cy="548640"/>
+          <p:cNvPr id="7" name="Shape 5"/>
+          <p:cNvSpPr/>
+          <p:nvPr/>
+        </p:nvSpPr>
+        <p:spPr>
+          <a:xfrm>
+            <a:off x="457200" y="4023360"/>
+            <a:ext cx="45720" cy="731520"/>
           </a:xfrm>
           <a:prstGeom prst="rect">
             <a:avLst/>
@@ -6248,14 +6087,14 @@
       </p:sp>
       <p:sp>
         <p:nvSpPr>
-          <p:cNvPr id="9" name="Text 7"/>
-          <p:cNvSpPr/>
-          <p:nvPr/>
-        </p:nvSpPr>
-        <p:spPr>
-          <a:xfrm>
-            <a:off x="640080" y="4206240"/>
-            <a:ext cx="7772400" cy="0"/>
+          <p:cNvPr id="8" name="Text 6"/>
+          <p:cNvSpPr/>
+          <p:nvPr/>
+        </p:nvSpPr>
+        <p:spPr>
+          <a:xfrm>
+            <a:off x="640080" y="4023360"/>
+            <a:ext cx="7772400" cy="731520"/>
           </a:xfrm>
           <a:prstGeom prst="rect">
             <a:avLst/>
@@ -6360,8 +6199,8 @@
         </p:nvSpPr>
         <p:spPr>
           <a:xfrm>
-            <a:off x="457200" y="457200"/>
-            <a:ext cx="8229600" cy="0"/>
+            <a:off x="457200" y="365760"/>
+            <a:ext cx="8229600" cy="274320"/>
           </a:xfrm>
           <a:prstGeom prst="rect">
             <a:avLst/>
@@ -6370,7 +6209,7 @@
           <a:ln/>
         </p:spPr>
         <p:txBody>
-          <a:bodyPr wrap="square" rtlCol="0" anchor="ctr"/>
+          <a:bodyPr wrap="square" rtlCol="0" anchor="t"/>
           <a:lstStyle/>
           <a:p>
             <a:pPr indent="0" marL="0">
@@ -6396,8 +6235,8 @@
         </p:nvSpPr>
         <p:spPr>
           <a:xfrm>
-            <a:off x="457200" y="731520"/>
-            <a:ext cx="8229600" cy="0"/>
+            <a:off x="457200" y="640080"/>
+            <a:ext cx="8229600" cy="548640"/>
           </a:xfrm>
           <a:prstGeom prst="rect">
             <a:avLst/>
@@ -6406,21 +6245,21 @@
           <a:ln/>
         </p:spPr>
         <p:txBody>
-          <a:bodyPr wrap="square" rtlCol="0" anchor="ctr"/>
-          <a:lstStyle/>
-          <a:p>
-            <a:pPr indent="0" marL="0">
-              <a:buNone/>
-            </a:pPr>
-            <a:r>
-              <a:rPr lang="en-US" sz="2400" b="1" dirty="0">
+          <a:bodyPr wrap="square" rtlCol="0" anchor="t"/>
+          <a:lstStyle/>
+          <a:p>
+            <a:pPr indent="0" marL="0">
+              <a:buNone/>
+            </a:pPr>
+            <a:r>
+              <a:rPr lang="en-US" sz="2800" b="1" dirty="0">
                 <a:solidFill>
                   <a:srgbClr val="FFFFFF"/>
                 </a:solidFill>
               </a:rPr>
               <a:t>The Toyoda precepts (1935)</a:t>
             </a:r>
-            <a:endParaRPr lang="en-US" sz="2400" dirty="0"/>
+            <a:endParaRPr lang="en-US" sz="2800" dirty="0"/>
           </a:p>
         </p:txBody>
       </p:sp>
@@ -6432,7 +6271,7 @@
         </p:nvSpPr>
         <p:spPr>
           <a:xfrm>
-            <a:off x="457200" y="1371600"/>
+            <a:off x="457200" y="1280160"/>
             <a:ext cx="8229600" cy="0"/>
           </a:xfrm>
           <a:prstGeom prst="line">
@@ -6455,8 +6294,8 @@
         </p:nvSpPr>
         <p:spPr>
           <a:xfrm>
-            <a:off x="457200" y="1645920"/>
-            <a:ext cx="8229600" cy="0"/>
+            <a:off x="457200" y="1463040"/>
+            <a:ext cx="8229600" cy="3474720"/>
           </a:xfrm>
           <a:prstGeom prst="rect">
             <a:avLst/>
@@ -6465,13 +6304,10 @@
           <a:ln/>
         </p:spPr>
         <p:txBody>
-          <a:bodyPr wrap="square" rtlCol="0" anchor="ctr"/>
-          <a:lstStyle/>
-          <a:p>
-            <a:pPr indent="0" marL="0">
-              <a:lnSpc>
-                <a:spcPts val="2400"/>
-              </a:lnSpc>
+          <a:bodyPr wrap="square" rtlCol="0" anchor="t"/>
+          <a:lstStyle/>
+          <a:p>
+            <a:pPr indent="0" marL="0">
               <a:buNone/>
             </a:pPr>
             <a:r>
@@ -6483,9 +6319,6 @@
               <a:t>1. Faithful to duties </a:t>
             </a:r>
             <a:pPr indent="0" marL="0">
-              <a:lnSpc>
-                <a:spcPts val="2400"/>
-              </a:lnSpc>
               <a:buNone/>
             </a:pPr>
             <a:r>
@@ -6498,9 +6331,6 @@
 </a:t>
             </a:r>
             <a:pPr indent="0" marL="0">
-              <a:lnSpc>
-                <a:spcPts val="2400"/>
-              </a:lnSpc>
               <a:buNone/>
             </a:pPr>
             <a:r>
@@ -6512,9 +6342,6 @@
               <a:t>2. Studiousness and creativity </a:t>
             </a:r>
             <a:pPr indent="0" marL="0">
-              <a:lnSpc>
-                <a:spcPts val="2400"/>
-              </a:lnSpc>
               <a:buNone/>
             </a:pPr>
             <a:r>
@@ -6527,9 +6354,6 @@
 </a:t>
             </a:r>
             <a:pPr indent="0" marL="0">
-              <a:lnSpc>
-                <a:spcPts val="2400"/>
-              </a:lnSpc>
               <a:buNone/>
             </a:pPr>
             <a:r>
@@ -6541,9 +6365,6 @@
               <a:t>3. Practicality </a:t>
             </a:r>
             <a:pPr indent="0" marL="0">
-              <a:lnSpc>
-                <a:spcPts val="2400"/>
-              </a:lnSpc>
               <a:buNone/>
             </a:pPr>
             <a:r>
@@ -6556,9 +6377,6 @@
 </a:t>
             </a:r>
             <a:pPr indent="0" marL="0">
-              <a:lnSpc>
-                <a:spcPts val="2400"/>
-              </a:lnSpc>
               <a:buNone/>
             </a:pPr>
             <a:r>
@@ -6570,9 +6388,6 @@
               <a:t>4. Foster a warm workplace </a:t>
             </a:r>
             <a:pPr indent="0" marL="0">
-              <a:lnSpc>
-                <a:spcPts val="2400"/>
-              </a:lnSpc>
               <a:buNone/>
             </a:pPr>
             <a:r>
@@ -6585,9 +6400,6 @@
 </a:t>
             </a:r>
             <a:pPr indent="0" marL="0">
-              <a:lnSpc>
-                <a:spcPts val="2400"/>
-              </a:lnSpc>
               <a:buNone/>
             </a:pPr>
             <a:r>
@@ -6599,9 +6411,6 @@
               <a:t>5. Profound respect </a:t>
             </a:r>
             <a:pPr indent="0" marL="0">
-              <a:lnSpc>
-                <a:spcPts val="2400"/>
-              </a:lnSpc>
               <a:buNone/>
             </a:pPr>
             <a:r>
@@ -6694,8 +6503,8 @@
         </p:nvSpPr>
         <p:spPr>
           <a:xfrm>
-            <a:off x="457200" y="457200"/>
-            <a:ext cx="8229600" cy="0"/>
+            <a:off x="457200" y="365760"/>
+            <a:ext cx="8229600" cy="274320"/>
           </a:xfrm>
           <a:prstGeom prst="rect">
             <a:avLst/>
@@ -6704,7 +6513,7 @@
           <a:ln/>
         </p:spPr>
         <p:txBody>
-          <a:bodyPr wrap="square" rtlCol="0" anchor="ctr"/>
+          <a:bodyPr wrap="square" rtlCol="0" anchor="t"/>
           <a:lstStyle/>
           <a:p>
             <a:pPr indent="0" marL="0">
@@ -6730,8 +6539,8 @@
         </p:nvSpPr>
         <p:spPr>
           <a:xfrm>
-            <a:off x="457200" y="731520"/>
-            <a:ext cx="8229600" cy="0"/>
+            <a:off x="457200" y="640080"/>
+            <a:ext cx="8229600" cy="548640"/>
           </a:xfrm>
           <a:prstGeom prst="rect">
             <a:avLst/>
@@ -6740,21 +6549,21 @@
           <a:ln/>
         </p:spPr>
         <p:txBody>
-          <a:bodyPr wrap="square" rtlCol="0" anchor="ctr"/>
-          <a:lstStyle/>
-          <a:p>
-            <a:pPr indent="0" marL="0">
-              <a:buNone/>
-            </a:pPr>
-            <a:r>
-              <a:rPr lang="en-US" sz="2400" b="1" dirty="0">
+          <a:bodyPr wrap="square" rtlCol="0" anchor="t"/>
+          <a:lstStyle/>
+          <a:p>
+            <a:pPr indent="0" marL="0">
+              <a:buNone/>
+            </a:pPr>
+            <a:r>
+              <a:rPr lang="en-US" sz="2800" b="1" dirty="0">
                 <a:solidFill>
                   <a:srgbClr val="FFFFFF"/>
                 </a:solidFill>
               </a:rPr>
               <a:t>Strategic intelligence</a:t>
             </a:r>
-            <a:endParaRPr lang="en-US" sz="2400" dirty="0"/>
+            <a:endParaRPr lang="en-US" sz="2800" dirty="0"/>
           </a:p>
         </p:txBody>
       </p:sp>
@@ -6766,7 +6575,7 @@
         </p:nvSpPr>
         <p:spPr>
           <a:xfrm>
-            <a:off x="457200" y="1371600"/>
+            <a:off x="457200" y="1280160"/>
             <a:ext cx="8229600" cy="0"/>
           </a:xfrm>
           <a:prstGeom prst="line">
@@ -6789,8 +6598,8 @@
         </p:nvSpPr>
         <p:spPr>
           <a:xfrm>
-            <a:off x="457200" y="1828800"/>
-            <a:ext cx="8229600" cy="0"/>
+            <a:off x="457200" y="1463040"/>
+            <a:ext cx="8229600" cy="3200400"/>
           </a:xfrm>
           <a:prstGeom prst="rect">
             <a:avLst/>
@@ -6799,7 +6608,7 @@
           <a:ln/>
         </p:spPr>
         <p:txBody>
-          <a:bodyPr wrap="square" rtlCol="0" anchor="ctr"/>
+          <a:bodyPr wrap="square" rtlCol="0" anchor="t"/>
           <a:lstStyle/>
           <a:p>
             <a:pPr indent="0" marL="0">
@@ -6814,7 +6623,33 @@
                   <a:srgbClr val="94A3B8"/>
                 </a:solidFill>
               </a:rPr>
-              <a:t>Planning is a continuous, systemic integration of external market realities with internal manufacturing capabilities. We analyze Toyota through canonical frameworks: SWOT, TOWS, Blue Ocean, BCG, and Porter's Five Forces. This top-down strategic planning phase ensures that multi-billion dollar capital expenditure decisions—like battery lab investments and factory retrofits—are insulated from short-term market hysteria.</a:t>
+              <a:t>Planning is a continuous, systemic integration of external market realities with internal manufacturing capabilities. We analyze Toyota through canonical frameworks: SWOT, TOWS, Blue Ocean, BCG, and Porter's Five Forces. </a:t>
+            </a:r>
+            <a:endParaRPr lang="en-US" sz="1600" dirty="0"/>
+          </a:p>
+          <a:p>
+            <a:pPr indent="0" marL="0">
+              <a:lnSpc>
+                <a:spcPts val="2400"/>
+              </a:lnSpc>
+              <a:buNone/>
+            </a:pPr>
+            <a:endParaRPr lang="en-US" sz="1600" dirty="0"/>
+          </a:p>
+          <a:p>
+            <a:pPr indent="0" marL="0">
+              <a:lnSpc>
+                <a:spcPts val="2400"/>
+              </a:lnSpc>
+              <a:buNone/>
+            </a:pPr>
+            <a:r>
+              <a:rPr lang="en-US" sz="1600" dirty="0">
+                <a:solidFill>
+                  <a:srgbClr val="94A3B8"/>
+                </a:solidFill>
+              </a:rPr>
+              <a:t>This top-down strategic planning phase ensures that multi-billion dollar capital expenditure decisions—like battery lab investments and factory retrofits—are insulated from short-term market hysteria.</a:t>
             </a:r>
             <a:endParaRPr lang="en-US" sz="1600" dirty="0"/>
           </a:p>
@@ -6898,8 +6733,8 @@
         </p:nvSpPr>
         <p:spPr>
           <a:xfrm>
-            <a:off x="457200" y="457200"/>
-            <a:ext cx="8229600" cy="0"/>
+            <a:off x="457200" y="365760"/>
+            <a:ext cx="8229600" cy="274320"/>
           </a:xfrm>
           <a:prstGeom prst="rect">
             <a:avLst/>
@@ -6908,7 +6743,7 @@
           <a:ln/>
         </p:spPr>
         <p:txBody>
-          <a:bodyPr wrap="square" rtlCol="0" anchor="ctr"/>
+          <a:bodyPr wrap="square" rtlCol="0" anchor="t"/>
           <a:lstStyle/>
           <a:p>
             <a:pPr indent="0" marL="0">
@@ -6934,8 +6769,8 @@
         </p:nvSpPr>
         <p:spPr>
           <a:xfrm>
-            <a:off x="457200" y="731520"/>
-            <a:ext cx="8229600" cy="0"/>
+            <a:off x="457200" y="640080"/>
+            <a:ext cx="8229600" cy="548640"/>
           </a:xfrm>
           <a:prstGeom prst="rect">
             <a:avLst/>
@@ -6944,21 +6779,21 @@
           <a:ln/>
         </p:spPr>
         <p:txBody>
-          <a:bodyPr wrap="square" rtlCol="0" anchor="ctr"/>
-          <a:lstStyle/>
-          <a:p>
-            <a:pPr indent="0" marL="0">
-              <a:buNone/>
-            </a:pPr>
-            <a:r>
-              <a:rPr lang="en-US" sz="2400" b="1" dirty="0">
+          <a:bodyPr wrap="square" rtlCol="0" anchor="t"/>
+          <a:lstStyle/>
+          <a:p>
+            <a:pPr indent="0" marL="0">
+              <a:buNone/>
+            </a:pPr>
+            <a:r>
+              <a:rPr lang="en-US" sz="2800" b="1" dirty="0">
                 <a:solidFill>
                   <a:srgbClr val="FFFFFF"/>
                 </a:solidFill>
               </a:rPr>
               <a:t>The SWOT matrix</a:t>
             </a:r>
-            <a:endParaRPr lang="en-US" sz="2400" dirty="0"/>
+            <a:endParaRPr lang="en-US" sz="2800" dirty="0"/>
           </a:p>
         </p:txBody>
       </p:sp>
@@ -6970,7 +6805,7 @@
         </p:nvSpPr>
         <p:spPr>
           <a:xfrm>
-            <a:off x="457200" y="1371600"/>
+            <a:off x="457200" y="1280160"/>
             <a:ext cx="8229600" cy="0"/>
           </a:xfrm>
           <a:prstGeom prst="line">
@@ -6993,8 +6828,8 @@
         </p:nvSpPr>
         <p:spPr>
           <a:xfrm>
-            <a:off x="457200" y="1554480"/>
-            <a:ext cx="3931920" cy="1554480"/>
+            <a:off x="457200" y="1463040"/>
+            <a:ext cx="3931920" cy="1645920"/>
           </a:xfrm>
           <a:prstGeom prst="rect">
             <a:avLst/>
@@ -7018,8 +6853,8 @@
         </p:nvSpPr>
         <p:spPr>
           <a:xfrm>
-            <a:off x="640080" y="1737360"/>
-            <a:ext cx="6858000" cy="0"/>
+            <a:off x="457200" y="1463040"/>
+            <a:ext cx="3931920" cy="1645920"/>
           </a:xfrm>
           <a:prstGeom prst="rect">
             <a:avLst/>
@@ -7028,45 +6863,21 @@
           <a:ln/>
         </p:spPr>
         <p:txBody>
-          <a:bodyPr wrap="square" rtlCol="0" anchor="ctr"/>
-          <a:lstStyle/>
-          <a:p>
-            <a:pPr indent="0" marL="0">
-              <a:buNone/>
-            </a:pPr>
-            <a:r>
-              <a:rPr lang="en-US" sz="1200" b="1" dirty="0">
+          <a:bodyPr wrap="square" lIns="127000" tIns="127000" rIns="127000" bIns="127000" rtlCol="0" anchor="t"/>
+          <a:lstStyle/>
+          <a:p>
+            <a:pPr indent="0" marL="0">
+              <a:buNone/>
+            </a:pPr>
+            <a:r>
+              <a:rPr lang="en-US" sz="1400" b="1" dirty="0">
                 <a:solidFill>
                   <a:srgbClr val="10B981"/>
                 </a:solidFill>
               </a:rPr>
-              <a:t>STRENGTHS</a:t>
-            </a:r>
-            <a:endParaRPr lang="en-US" sz="1200" dirty="0"/>
-          </a:p>
-        </p:txBody>
-      </p:sp>
-      <p:sp>
-        <p:nvSpPr>
-          <p:cNvPr id="7" name="Text 5"/>
-          <p:cNvSpPr/>
-          <p:nvPr/>
-        </p:nvSpPr>
-        <p:spPr>
-          <a:xfrm>
-            <a:off x="640080" y="2103120"/>
-            <a:ext cx="3657600" cy="0"/>
-          </a:xfrm>
-          <a:prstGeom prst="rect">
-            <a:avLst/>
-          </a:prstGeom>
-          <a:noFill/>
-          <a:ln/>
-        </p:spPr>
-        <p:txBody>
-          <a:bodyPr wrap="square" rtlCol="0" anchor="ctr"/>
-          <a:lstStyle/>
-          <a:p>
+              <a:t>STRENGTHS
+</a:t>
+            </a:r>
             <a:pPr indent="0" marL="0">
               <a:buNone/>
             </a:pPr>
@@ -7078,7 +6889,7 @@
               </a:rPr>
               <a:t>• Best-selling automaker globally (5.5M units H1 2025).</a:t>
             </a:r>
-            <a:endParaRPr lang="en-US" sz="1200" dirty="0"/>
+            <a:endParaRPr lang="en-US" sz="1400" dirty="0"/>
           </a:p>
           <a:p>
             <a:pPr indent="0" marL="0">
@@ -7092,7 +6903,7 @@
               </a:rPr>
               <a:t>• Resilient Toyota Production System (TPS).</a:t>
             </a:r>
-            <a:endParaRPr lang="en-US" sz="1200" dirty="0"/>
+            <a:endParaRPr lang="en-US" sz="1400" dirty="0"/>
           </a:p>
           <a:p>
             <a:pPr indent="0" marL="0">
@@ -7106,20 +6917,20 @@
               </a:rPr>
               <a:t>• Multi-pathway portfolio (ICE, HEV, PHEV, BEV, FCEV).</a:t>
             </a:r>
-            <a:endParaRPr lang="en-US" sz="1200" dirty="0"/>
-          </a:p>
-        </p:txBody>
-      </p:sp>
-      <p:sp>
-        <p:nvSpPr>
-          <p:cNvPr id="8" name="Shape 6"/>
-          <p:cNvSpPr/>
-          <p:nvPr/>
-        </p:nvSpPr>
-        <p:spPr>
-          <a:xfrm>
-            <a:off x="4572000" y="1554480"/>
-            <a:ext cx="3931920" cy="1554480"/>
+            <a:endParaRPr lang="en-US" sz="1400" dirty="0"/>
+          </a:p>
+        </p:txBody>
+      </p:sp>
+      <p:sp>
+        <p:nvSpPr>
+          <p:cNvPr id="7" name="Shape 5"/>
+          <p:cNvSpPr/>
+          <p:nvPr/>
+        </p:nvSpPr>
+        <p:spPr>
+          <a:xfrm>
+            <a:off x="4663440" y="1463040"/>
+            <a:ext cx="3931920" cy="1645920"/>
           </a:xfrm>
           <a:prstGeom prst="rect">
             <a:avLst/>
@@ -7137,14 +6948,14 @@
       </p:sp>
       <p:sp>
         <p:nvSpPr>
-          <p:cNvPr id="9" name="Text 7"/>
-          <p:cNvSpPr/>
-          <p:nvPr/>
-        </p:nvSpPr>
-        <p:spPr>
-          <a:xfrm>
-            <a:off x="4754880" y="1737360"/>
-            <a:ext cx="6858000" cy="0"/>
+          <p:cNvPr id="8" name="Text 6"/>
+          <p:cNvSpPr/>
+          <p:nvPr/>
+        </p:nvSpPr>
+        <p:spPr>
+          <a:xfrm>
+            <a:off x="4663440" y="1463040"/>
+            <a:ext cx="3931920" cy="1645920"/>
           </a:xfrm>
           <a:prstGeom prst="rect">
             <a:avLst/>
@@ -7153,45 +6964,21 @@
           <a:ln/>
         </p:spPr>
         <p:txBody>
-          <a:bodyPr wrap="square" rtlCol="0" anchor="ctr"/>
-          <a:lstStyle/>
-          <a:p>
-            <a:pPr indent="0" marL="0">
-              <a:buNone/>
-            </a:pPr>
-            <a:r>
-              <a:rPr lang="en-US" sz="1200" b="1" dirty="0">
+          <a:bodyPr wrap="square" lIns="127000" tIns="127000" rIns="127000" bIns="127000" rtlCol="0" anchor="t"/>
+          <a:lstStyle/>
+          <a:p>
+            <a:pPr indent="0" marL="0">
+              <a:buNone/>
+            </a:pPr>
+            <a:r>
+              <a:rPr lang="en-US" sz="1400" b="1" dirty="0">
                 <a:solidFill>
                   <a:srgbClr val="F97316"/>
                 </a:solidFill>
               </a:rPr>
-              <a:t>WEAKNESSES</a:t>
-            </a:r>
-            <a:endParaRPr lang="en-US" sz="1200" dirty="0"/>
-          </a:p>
-        </p:txBody>
-      </p:sp>
-      <p:sp>
-        <p:nvSpPr>
-          <p:cNvPr id="10" name="Text 8"/>
-          <p:cNvSpPr/>
-          <p:nvPr/>
-        </p:nvSpPr>
-        <p:spPr>
-          <a:xfrm>
-            <a:off x="4754880" y="2103120"/>
-            <a:ext cx="3657600" cy="0"/>
-          </a:xfrm>
-          <a:prstGeom prst="rect">
-            <a:avLst/>
-          </a:prstGeom>
-          <a:noFill/>
-          <a:ln/>
-        </p:spPr>
-        <p:txBody>
-          <a:bodyPr wrap="square" rtlCol="0" anchor="ctr"/>
-          <a:lstStyle/>
-          <a:p>
+              <a:t>WEAKNESSES
+</a:t>
+            </a:r>
             <a:pPr indent="0" marL="0">
               <a:buNone/>
             </a:pPr>
@@ -7203,7 +6990,7 @@
               </a:rPr>
               <a:t>• Over-reliance on domestic market and US trucks.</a:t>
             </a:r>
-            <a:endParaRPr lang="en-US" sz="1200" dirty="0"/>
+            <a:endParaRPr lang="en-US" sz="1400" dirty="0"/>
           </a:p>
           <a:p>
             <a:pPr indent="0" marL="0">
@@ -7217,7 +7004,7 @@
               </a:rPr>
               <a:t>• Bureaucratic rigidity slowing agile decisions.</a:t>
             </a:r>
-            <a:endParaRPr lang="en-US" sz="1200" dirty="0"/>
+            <a:endParaRPr lang="en-US" sz="1400" dirty="0"/>
           </a:p>
           <a:p>
             <a:pPr indent="0" marL="0">
@@ -7231,20 +7018,20 @@
               </a:rPr>
               <a:t>• Operating margins compressed to 10.0% due to capital expenditure on BEVs.</a:t>
             </a:r>
-            <a:endParaRPr lang="en-US" sz="1200" dirty="0"/>
-          </a:p>
-        </p:txBody>
-      </p:sp>
-      <p:sp>
-        <p:nvSpPr>
-          <p:cNvPr id="11" name="Shape 9"/>
+            <a:endParaRPr lang="en-US" sz="1400" dirty="0"/>
+          </a:p>
+        </p:txBody>
+      </p:sp>
+      <p:sp>
+        <p:nvSpPr>
+          <p:cNvPr id="9" name="Shape 7"/>
           <p:cNvSpPr/>
           <p:nvPr/>
         </p:nvSpPr>
         <p:spPr>
           <a:xfrm>
             <a:off x="457200" y="3291840"/>
-            <a:ext cx="3931920" cy="1554480"/>
+            <a:ext cx="3931920" cy="1645920"/>
           </a:xfrm>
           <a:prstGeom prst="rect">
             <a:avLst/>
@@ -7262,14 +7049,14 @@
       </p:sp>
       <p:sp>
         <p:nvSpPr>
-          <p:cNvPr id="12" name="Text 10"/>
-          <p:cNvSpPr/>
-          <p:nvPr/>
-        </p:nvSpPr>
-        <p:spPr>
-          <a:xfrm>
-            <a:off x="640080" y="3474720"/>
-            <a:ext cx="6858000" cy="0"/>
+          <p:cNvPr id="10" name="Text 8"/>
+          <p:cNvSpPr/>
+          <p:nvPr/>
+        </p:nvSpPr>
+        <p:spPr>
+          <a:xfrm>
+            <a:off x="457200" y="3291840"/>
+            <a:ext cx="3931920" cy="1645920"/>
           </a:xfrm>
           <a:prstGeom prst="rect">
             <a:avLst/>
@@ -7278,45 +7065,21 @@
           <a:ln/>
         </p:spPr>
         <p:txBody>
-          <a:bodyPr wrap="square" rtlCol="0" anchor="ctr"/>
-          <a:lstStyle/>
-          <a:p>
-            <a:pPr indent="0" marL="0">
-              <a:buNone/>
-            </a:pPr>
-            <a:r>
-              <a:rPr lang="en-US" sz="1200" b="1" dirty="0">
+          <a:bodyPr wrap="square" lIns="127000" tIns="127000" rIns="127000" bIns="127000" rtlCol="0" anchor="t"/>
+          <a:lstStyle/>
+          <a:p>
+            <a:pPr indent="0" marL="0">
+              <a:buNone/>
+            </a:pPr>
+            <a:r>
+              <a:rPr lang="en-US" sz="1400" b="1" dirty="0">
                 <a:solidFill>
                   <a:srgbClr val="3B82F6"/>
                 </a:solidFill>
               </a:rPr>
-              <a:t>OPPORTUNITIES</a:t>
-            </a:r>
-            <a:endParaRPr lang="en-US" sz="1200" dirty="0"/>
-          </a:p>
-        </p:txBody>
-      </p:sp>
-      <p:sp>
-        <p:nvSpPr>
-          <p:cNvPr id="13" name="Text 11"/>
-          <p:cNvSpPr/>
-          <p:nvPr/>
-        </p:nvSpPr>
-        <p:spPr>
-          <a:xfrm>
-            <a:off x="640080" y="3840480"/>
-            <a:ext cx="3657600" cy="0"/>
-          </a:xfrm>
-          <a:prstGeom prst="rect">
-            <a:avLst/>
-          </a:prstGeom>
-          <a:noFill/>
-          <a:ln/>
-        </p:spPr>
-        <p:txBody>
-          <a:bodyPr wrap="square" rtlCol="0" anchor="ctr"/>
-          <a:lstStyle/>
-          <a:p>
+              <a:t>OPPORTUNITIES
+</a:t>
+            </a:r>
             <a:pPr indent="0" marL="0">
               <a:buNone/>
             </a:pPr>
@@ -7328,7 +7091,7 @@
               </a:rPr>
               <a:t>• Weak Yen boosting export profitability.</a:t>
             </a:r>
-            <a:endParaRPr lang="en-US" sz="1200" dirty="0"/>
+            <a:endParaRPr lang="en-US" sz="1400" dirty="0"/>
           </a:p>
           <a:p>
             <a:pPr indent="0" marL="0">
@@ -7342,7 +7105,7 @@
               </a:rPr>
               <a:t>• Surging hybrid demand against range anxiety.</a:t>
             </a:r>
-            <a:endParaRPr lang="en-US" sz="1200" dirty="0"/>
+            <a:endParaRPr lang="en-US" sz="1400" dirty="0"/>
           </a:p>
           <a:p>
             <a:pPr indent="0" marL="0">
@@ -7356,20 +7119,20 @@
               </a:rPr>
               <a:t>• Government subsidies for eco-mobility localization.</a:t>
             </a:r>
-            <a:endParaRPr lang="en-US" sz="1200" dirty="0"/>
-          </a:p>
-        </p:txBody>
-      </p:sp>
-      <p:sp>
-        <p:nvSpPr>
-          <p:cNvPr id="14" name="Shape 12"/>
-          <p:cNvSpPr/>
-          <p:nvPr/>
-        </p:nvSpPr>
-        <p:spPr>
-          <a:xfrm>
-            <a:off x="4572000" y="3291840"/>
-            <a:ext cx="3931920" cy="1554480"/>
+            <a:endParaRPr lang="en-US" sz="1400" dirty="0"/>
+          </a:p>
+        </p:txBody>
+      </p:sp>
+      <p:sp>
+        <p:nvSpPr>
+          <p:cNvPr id="11" name="Shape 9"/>
+          <p:cNvSpPr/>
+          <p:nvPr/>
+        </p:nvSpPr>
+        <p:spPr>
+          <a:xfrm>
+            <a:off x="4663440" y="3291840"/>
+            <a:ext cx="3931920" cy="1645920"/>
           </a:xfrm>
           <a:prstGeom prst="rect">
             <a:avLst/>
@@ -7387,14 +7150,14 @@
       </p:sp>
       <p:sp>
         <p:nvSpPr>
-          <p:cNvPr id="15" name="Text 13"/>
-          <p:cNvSpPr/>
-          <p:nvPr/>
-        </p:nvSpPr>
-        <p:spPr>
-          <a:xfrm>
-            <a:off x="4754880" y="3474720"/>
-            <a:ext cx="6858000" cy="0"/>
+          <p:cNvPr id="12" name="Text 10"/>
+          <p:cNvSpPr/>
+          <p:nvPr/>
+        </p:nvSpPr>
+        <p:spPr>
+          <a:xfrm>
+            <a:off x="4663440" y="3291840"/>
+            <a:ext cx="3931920" cy="1645920"/>
           </a:xfrm>
           <a:prstGeom prst="rect">
             <a:avLst/>
@@ -7403,45 +7166,21 @@
           <a:ln/>
         </p:spPr>
         <p:txBody>
-          <a:bodyPr wrap="square" rtlCol="0" anchor="ctr"/>
-          <a:lstStyle/>
-          <a:p>
-            <a:pPr indent="0" marL="0">
-              <a:buNone/>
-            </a:pPr>
-            <a:r>
-              <a:rPr lang="en-US" sz="1200" b="1" dirty="0">
+          <a:bodyPr wrap="square" lIns="127000" tIns="127000" rIns="127000" bIns="127000" rtlCol="0" anchor="t"/>
+          <a:lstStyle/>
+          <a:p>
+            <a:pPr indent="0" marL="0">
+              <a:buNone/>
+            </a:pPr>
+            <a:r>
+              <a:rPr lang="en-US" sz="1400" b="1" dirty="0">
                 <a:solidFill>
                   <a:srgbClr val="EF4444"/>
                 </a:solidFill>
               </a:rPr>
-              <a:t>THREATS</a:t>
-            </a:r>
-            <a:endParaRPr lang="en-US" sz="1200" dirty="0"/>
-          </a:p>
-        </p:txBody>
-      </p:sp>
-      <p:sp>
-        <p:nvSpPr>
-          <p:cNvPr id="16" name="Text 14"/>
-          <p:cNvSpPr/>
-          <p:nvPr/>
-        </p:nvSpPr>
-        <p:spPr>
-          <a:xfrm>
-            <a:off x="4754880" y="3840480"/>
-            <a:ext cx="3657600" cy="0"/>
-          </a:xfrm>
-          <a:prstGeom prst="rect">
-            <a:avLst/>
-          </a:prstGeom>
-          <a:noFill/>
-          <a:ln/>
-        </p:spPr>
-        <p:txBody>
-          <a:bodyPr wrap="square" rtlCol="0" anchor="ctr"/>
-          <a:lstStyle/>
-          <a:p>
+              <a:t>THREATS
+</a:t>
+            </a:r>
             <a:pPr indent="0" marL="0">
               <a:buNone/>
             </a:pPr>
@@ -7453,7 +7192,7 @@
               </a:rPr>
               <a:t>• Geopolitical instability and escalating US tariffs.</a:t>
             </a:r>
-            <a:endParaRPr lang="en-US" sz="1200" dirty="0"/>
+            <a:endParaRPr lang="en-US" sz="1400" dirty="0"/>
           </a:p>
           <a:p>
             <a:pPr indent="0" marL="0">
@@ -7467,7 +7206,7 @@
               </a:rPr>
               <a:t>• Aggressive low-cost Chinese EV OEMs (BYD, NIO).</a:t>
             </a:r>
-            <a:endParaRPr lang="en-US" sz="1200" dirty="0"/>
+            <a:endParaRPr lang="en-US" sz="1400" dirty="0"/>
           </a:p>
           <a:p>
             <a:pPr indent="0" marL="0">
@@ -7481,7 +7220,7 @@
               </a:rPr>
               <a:t>• Legislative shifting of EV tax credits.</a:t>
             </a:r>
-            <a:endParaRPr lang="en-US" sz="1200" dirty="0"/>
+            <a:endParaRPr lang="en-US" sz="1400" dirty="0"/>
           </a:p>
         </p:txBody>
       </p:sp>
@@ -7563,8 +7302,8 @@
         </p:nvSpPr>
         <p:spPr>
           <a:xfrm>
-            <a:off x="457200" y="457200"/>
-            <a:ext cx="8229600" cy="0"/>
+            <a:off x="457200" y="365760"/>
+            <a:ext cx="8229600" cy="274320"/>
           </a:xfrm>
           <a:prstGeom prst="rect">
             <a:avLst/>
@@ -7573,7 +7312,7 @@
           <a:ln/>
         </p:spPr>
         <p:txBody>
-          <a:bodyPr wrap="square" rtlCol="0" anchor="ctr"/>
+          <a:bodyPr wrap="square" rtlCol="0" anchor="t"/>
           <a:lstStyle/>
           <a:p>
             <a:pPr indent="0" marL="0">
@@ -7599,8 +7338,8 @@
         </p:nvSpPr>
         <p:spPr>
           <a:xfrm>
-            <a:off x="457200" y="731520"/>
-            <a:ext cx="8229600" cy="0"/>
+            <a:off x="457200" y="640080"/>
+            <a:ext cx="8229600" cy="548640"/>
           </a:xfrm>
           <a:prstGeom prst="rect">
             <a:avLst/>
@@ -7609,21 +7348,21 @@
           <a:ln/>
         </p:spPr>
         <p:txBody>
-          <a:bodyPr wrap="square" rtlCol="0" anchor="ctr"/>
-          <a:lstStyle/>
-          <a:p>
-            <a:pPr indent="0" marL="0">
-              <a:buNone/>
-            </a:pPr>
-            <a:r>
-              <a:rPr lang="en-US" sz="2400" b="1" dirty="0">
+          <a:bodyPr wrap="square" rtlCol="0" anchor="t"/>
+          <a:lstStyle/>
+          <a:p>
+            <a:pPr indent="0" marL="0">
+              <a:buNone/>
+            </a:pPr>
+            <a:r>
+              <a:rPr lang="en-US" sz="2800" b="1" dirty="0">
                 <a:solidFill>
                   <a:srgbClr val="FFFFFF"/>
                 </a:solidFill>
               </a:rPr>
               <a:t>TOWS prescriptions</a:t>
             </a:r>
-            <a:endParaRPr lang="en-US" sz="2400" dirty="0"/>
+            <a:endParaRPr lang="en-US" sz="2800" dirty="0"/>
           </a:p>
         </p:txBody>
       </p:sp>
@@ -7635,7 +7374,7 @@
         </p:nvSpPr>
         <p:spPr>
           <a:xfrm>
-            <a:off x="457200" y="1371600"/>
+            <a:off x="457200" y="1280160"/>
             <a:ext cx="8229600" cy="0"/>
           </a:xfrm>
           <a:prstGeom prst="line">
@@ -7665,7 +7404,7 @@
           </p:nvPr>
         </p:nvGraphicFramePr>
         <p:xfrm>
-          <a:off x="457200" y="1645920"/>
+          <a:off x="457200" y="1463040"/>
           <a:ext cx="6858000" cy="914400"/>
         </p:xfrm>
         <a:graphic>
@@ -7673,10 +7412,10 @@
             <a:tbl>
               <a:tblPr/>
               <a:tblGrid>
-                <a:gridCol w="1828800"/>
-                <a:gridCol w="6400800"/>
+                <a:gridCol w="2286000"/>
+                <a:gridCol w="5943600"/>
               </a:tblGrid>
-              <a:tr h="457200">
+              <a:tr h="0">
                 <a:tc>
                   <a:txBody>
                     <a:bodyPr/>
@@ -7696,7 +7435,7 @@
                       <a:endParaRPr lang="en-US" sz="1200" dirty="0"/>
                     </a:p>
                   </a:txBody>
-                  <a:tcPr marL="91440" marR="91440" marT="45720" marB="45720" anchor="t">
+                  <a:tcPr marL="127000" marR="127000" marT="127000" marB="127000" anchor="t">
                     <a:lnL w="12700" cap="flat" cmpd="sng" algn="ctr">
                       <a:solidFill>
                         <a:srgbClr val="1E293B"/>
@@ -7757,7 +7496,7 @@
                       <a:endParaRPr lang="en-US" sz="1200" dirty="0"/>
                     </a:p>
                   </a:txBody>
-                  <a:tcPr marL="91440" marR="91440" marT="45720" marB="45720" anchor="t">
+                  <a:tcPr marL="127000" marR="127000" marT="127000" marB="127000" anchor="t">
                     <a:lnL w="12700" cap="flat" cmpd="sng" algn="ctr">
                       <a:solidFill>
                         <a:srgbClr val="1E293B"/>
@@ -7800,7 +7539,7 @@
                   </a:tcPr>
                 </a:tc>
               </a:tr>
-              <a:tr h="457200">
+              <a:tr h="0">
                 <a:tc>
                   <a:txBody>
                     <a:bodyPr/>
@@ -7834,7 +7573,7 @@
                       <a:endParaRPr lang="en-US" sz="1200" dirty="0"/>
                     </a:p>
                   </a:txBody>
-                  <a:tcPr marL="91440" marR="91440" marT="45720" marB="45720" anchor="t">
+                  <a:tcPr marL="127000" marR="127000" marT="127000" marB="127000" anchor="t">
                     <a:lnL w="12700" cap="flat" cmpd="sng" algn="ctr">
                       <a:solidFill>
                         <a:srgbClr val="1E293B"/>
@@ -7895,7 +7634,7 @@
                       <a:endParaRPr lang="en-US" sz="1200" dirty="0"/>
                     </a:p>
                   </a:txBody>
-                  <a:tcPr marL="91440" marR="91440" marT="45720" marB="45720" anchor="t">
+                  <a:tcPr marL="127000" marR="127000" marT="127000" marB="127000" anchor="t">
                     <a:lnL w="12700" cap="flat" cmpd="sng" algn="ctr">
                       <a:solidFill>
                         <a:srgbClr val="1E293B"/>
@@ -7938,7 +7677,7 @@
                   </a:tcPr>
                 </a:tc>
               </a:tr>
-              <a:tr h="457200">
+              <a:tr h="0">
                 <a:tc>
                   <a:txBody>
                     <a:bodyPr/>
@@ -7972,7 +7711,7 @@
                       <a:endParaRPr lang="en-US" sz="1200" dirty="0"/>
                     </a:p>
                   </a:txBody>
-                  <a:tcPr marL="91440" marR="91440" marT="45720" marB="45720" anchor="t">
+                  <a:tcPr marL="127000" marR="127000" marT="127000" marB="127000" anchor="t">
                     <a:lnL w="12700" cap="flat" cmpd="sng" algn="ctr">
                       <a:solidFill>
                         <a:srgbClr val="1E293B"/>
@@ -8033,7 +7772,7 @@
                       <a:endParaRPr lang="en-US" sz="1200" dirty="0"/>
                     </a:p>
                   </a:txBody>
-                  <a:tcPr marL="91440" marR="91440" marT="45720" marB="45720" anchor="t">
+                  <a:tcPr marL="127000" marR="127000" marT="127000" marB="127000" anchor="t">
                     <a:lnL w="12700" cap="flat" cmpd="sng" algn="ctr">
                       <a:solidFill>
                         <a:srgbClr val="1E293B"/>
@@ -8076,7 +7815,7 @@
                   </a:tcPr>
                 </a:tc>
               </a:tr>
-              <a:tr h="457200">
+              <a:tr h="0">
                 <a:tc>
                   <a:txBody>
                     <a:bodyPr/>
@@ -8110,7 +7849,7 @@
                       <a:endParaRPr lang="en-US" sz="1200" dirty="0"/>
                     </a:p>
                   </a:txBody>
-                  <a:tcPr marL="91440" marR="91440" marT="45720" marB="45720" anchor="t">
+                  <a:tcPr marL="127000" marR="127000" marT="127000" marB="127000" anchor="t">
                     <a:lnL w="12700" cap="flat" cmpd="sng" algn="ctr">
                       <a:solidFill>
                         <a:srgbClr val="1E293B"/>
@@ -8171,7 +7910,7 @@
                       <a:endParaRPr lang="en-US" sz="1200" dirty="0"/>
                     </a:p>
                   </a:txBody>
-                  <a:tcPr marL="91440" marR="91440" marT="45720" marB="45720" anchor="t">
+                  <a:tcPr marL="127000" marR="127000" marT="127000" marB="127000" anchor="t">
                     <a:lnL w="12700" cap="flat" cmpd="sng" algn="ctr">
                       <a:solidFill>
                         <a:srgbClr val="1E293B"/>
@@ -8296,8 +8035,8 @@
         </p:nvSpPr>
         <p:spPr>
           <a:xfrm>
-            <a:off x="457200" y="457200"/>
-            <a:ext cx="8229600" cy="0"/>
+            <a:off x="457200" y="365760"/>
+            <a:ext cx="8229600" cy="274320"/>
           </a:xfrm>
           <a:prstGeom prst="rect">
             <a:avLst/>
@@ -8306,7 +8045,7 @@
           <a:ln/>
         </p:spPr>
         <p:txBody>
-          <a:bodyPr wrap="square" rtlCol="0" anchor="ctr"/>
+          <a:bodyPr wrap="square" rtlCol="0" anchor="t"/>
           <a:lstStyle/>
           <a:p>
             <a:pPr indent="0" marL="0">
@@ -8332,8 +8071,8 @@
         </p:nvSpPr>
         <p:spPr>
           <a:xfrm>
-            <a:off x="457200" y="731520"/>
-            <a:ext cx="8229600" cy="0"/>
+            <a:off x="457200" y="640080"/>
+            <a:ext cx="8229600" cy="548640"/>
           </a:xfrm>
           <a:prstGeom prst="rect">
             <a:avLst/>
@@ -8342,21 +8081,21 @@
           <a:ln/>
         </p:spPr>
         <p:txBody>
-          <a:bodyPr wrap="square" rtlCol="0" anchor="ctr"/>
-          <a:lstStyle/>
-          <a:p>
-            <a:pPr indent="0" marL="0">
-              <a:buNone/>
-            </a:pPr>
-            <a:r>
-              <a:rPr lang="en-US" sz="2400" b="1" dirty="0">
+          <a:bodyPr wrap="square" rtlCol="0" anchor="t"/>
+          <a:lstStyle/>
+          <a:p>
+            <a:pPr indent="0" marL="0">
+              <a:buNone/>
+            </a:pPr>
+            <a:r>
+              <a:rPr lang="en-US" sz="2800" b="1" dirty="0">
                 <a:solidFill>
                   <a:srgbClr val="FFFFFF"/>
                 </a:solidFill>
               </a:rPr>
               <a:t>Blue ocean (ERRC)</a:t>
             </a:r>
-            <a:endParaRPr lang="en-US" sz="2400" dirty="0"/>
+            <a:endParaRPr lang="en-US" sz="2800" dirty="0"/>
           </a:p>
         </p:txBody>
       </p:sp>
@@ -8368,7 +8107,7 @@
         </p:nvSpPr>
         <p:spPr>
           <a:xfrm>
-            <a:off x="457200" y="1371600"/>
+            <a:off x="457200" y="1280160"/>
             <a:ext cx="8229600" cy="0"/>
           </a:xfrm>
           <a:prstGeom prst="line">
@@ -8391,8 +8130,8 @@
         </p:nvSpPr>
         <p:spPr>
           <a:xfrm>
-            <a:off x="457200" y="1645920"/>
-            <a:ext cx="6858000" cy="0"/>
+            <a:off x="457200" y="1463040"/>
+            <a:ext cx="3840480" cy="1463040"/>
           </a:xfrm>
           <a:prstGeom prst="rect">
             <a:avLst/>
@@ -8401,7 +8140,7 @@
           <a:ln/>
         </p:spPr>
         <p:txBody>
-          <a:bodyPr wrap="square" rtlCol="0" anchor="ctr"/>
+          <a:bodyPr wrap="square" rtlCol="0" anchor="t"/>
           <a:lstStyle/>
           <a:p>
             <a:pPr indent="0" marL="0">
@@ -8413,7 +8152,19 @@
                   <a:srgbClr val="EF4444"/>
                 </a:solidFill>
               </a:rPr>
-              <a:t>ELIMINATE</a:t>
+              <a:t>ELIMINATE
+</a:t>
+            </a:r>
+            <a:pPr indent="0" marL="0">
+              <a:buNone/>
+            </a:pPr>
+            <a:r>
+              <a:rPr lang="en-US" sz="1200" dirty="0">
+                <a:solidFill>
+                  <a:srgbClr val="FFFFFF"/>
+                </a:solidFill>
+              </a:rPr>
+              <a:t>The archaic single-powertrain dependency across new model platforms. Future vehicle platforms must natively support ICE, HEV, and BEV drivetrains interchangeably on the exact same assembly lines to eliminate re-tooling dead time.</a:t>
             </a:r>
             <a:endParaRPr lang="en-US" sz="1400" dirty="0"/>
           </a:p>
@@ -8427,8 +8178,8 @@
         </p:nvSpPr>
         <p:spPr>
           <a:xfrm>
-            <a:off x="457200" y="1920240"/>
-            <a:ext cx="3657600" cy="0"/>
+            <a:off x="4846320" y="1463040"/>
+            <a:ext cx="3840480" cy="1463040"/>
           </a:xfrm>
           <a:prstGeom prst="rect">
             <a:avLst/>
@@ -8437,9 +8188,21 @@
           <a:ln/>
         </p:spPr>
         <p:txBody>
-          <a:bodyPr wrap="square" rtlCol="0" anchor="ctr"/>
-          <a:lstStyle/>
-          <a:p>
+          <a:bodyPr wrap="square" rtlCol="0" anchor="t"/>
+          <a:lstStyle/>
+          <a:p>
+            <a:pPr indent="0" marL="0">
+              <a:buNone/>
+            </a:pPr>
+            <a:r>
+              <a:rPr lang="en-US" sz="1400" b="1" dirty="0">
+                <a:solidFill>
+                  <a:srgbClr val="F97316"/>
+                </a:solidFill>
+              </a:rPr>
+              <a:t>REDUCE
+</a:t>
+            </a:r>
             <a:pPr indent="0" marL="0">
               <a:buNone/>
             </a:pPr>
@@ -8449,9 +8212,9 @@
                   <a:srgbClr val="FFFFFF"/>
                 </a:solidFill>
               </a:rPr>
-              <a:t>The archaic single-powertrain dependency across new model platforms. Future vehicle platforms must natively support ICE, HEV, and BEV drivetrains interchangeably on the exact same assembly lines to eliminate re-tooling dead time.</a:t>
-            </a:r>
-            <a:endParaRPr lang="en-US" sz="1200" dirty="0"/>
+              <a:t>Corporate break-even volume and crippling reliance on hyper-expensive, rare-earth intensive battery-only architectures that restrict profitability to high-income luxury demographics.</a:t>
+            </a:r>
+            <a:endParaRPr lang="en-US" sz="1400" dirty="0"/>
           </a:p>
         </p:txBody>
       </p:sp>
@@ -8463,8 +8226,8 @@
         </p:nvSpPr>
         <p:spPr>
           <a:xfrm>
-            <a:off x="4572000" y="1645920"/>
-            <a:ext cx="6858000" cy="0"/>
+            <a:off x="457200" y="3108960"/>
+            <a:ext cx="3840480" cy="1463040"/>
           </a:xfrm>
           <a:prstGeom prst="rect">
             <a:avLst/>
@@ -8473,7 +8236,7 @@
           <a:ln/>
         </p:spPr>
         <p:txBody>
-          <a:bodyPr wrap="square" rtlCol="0" anchor="ctr"/>
+          <a:bodyPr wrap="square" rtlCol="0" anchor="t"/>
           <a:lstStyle/>
           <a:p>
             <a:pPr indent="0" marL="0">
@@ -8482,10 +8245,22 @@
             <a:r>
               <a:rPr lang="en-US" sz="1400" b="1" dirty="0">
                 <a:solidFill>
-                  <a:srgbClr val="F97316"/>
-                </a:solidFill>
-              </a:rPr>
-              <a:t>REDUCE</a:t>
+                  <a:srgbClr val="10B981"/>
+                </a:solidFill>
+              </a:rPr>
+              <a:t>RAISE
+</a:t>
+            </a:r>
+            <a:pPr indent="0" marL="0">
+              <a:buNone/>
+            </a:pPr>
+            <a:r>
+              <a:rPr lang="en-US" sz="1200" dirty="0">
+                <a:solidFill>
+                  <a:srgbClr val="FFFFFF"/>
+                </a:solidFill>
+              </a:rPr>
+              <a:t>The global accessibility of electrified and sustainable mobility via affordable, highly durable HEV (hybrid) models across lower-to-middle income brackets practically everywhere.</a:t>
             </a:r>
             <a:endParaRPr lang="en-US" sz="1400" dirty="0"/>
           </a:p>
@@ -8499,8 +8274,8 @@
         </p:nvSpPr>
         <p:spPr>
           <a:xfrm>
-            <a:off x="4572000" y="1920240"/>
-            <a:ext cx="3657600" cy="0"/>
+            <a:off x="4846320" y="3108960"/>
+            <a:ext cx="3840480" cy="1463040"/>
           </a:xfrm>
           <a:prstGeom prst="rect">
             <a:avLst/>
@@ -8509,9 +8284,21 @@
           <a:ln/>
         </p:spPr>
         <p:txBody>
-          <a:bodyPr wrap="square" rtlCol="0" anchor="ctr"/>
-          <a:lstStyle/>
-          <a:p>
+          <a:bodyPr wrap="square" rtlCol="0" anchor="t"/>
+          <a:lstStyle/>
+          <a:p>
+            <a:pPr indent="0" marL="0">
+              <a:buNone/>
+            </a:pPr>
+            <a:r>
+              <a:rPr lang="en-US" sz="1400" b="1" dirty="0">
+                <a:solidFill>
+                  <a:srgbClr val="3B82F6"/>
+                </a:solidFill>
+              </a:rPr>
+              <a:t>CREATE
+</a:t>
+            </a:r>
             <a:pPr indent="0" marL="0">
               <a:buNone/>
             </a:pPr>
@@ -8521,153 +8308,9 @@
                   <a:srgbClr val="FFFFFF"/>
                 </a:solidFill>
               </a:rPr>
-              <a:t>Corporate break-even volume and crippling reliance on hyper-expensive, rare-earth intensive battery-only architectures that restrict profitability to high-income luxury demographics.</a:t>
-            </a:r>
-            <a:endParaRPr lang="en-US" sz="1200" dirty="0"/>
-          </a:p>
-        </p:txBody>
-      </p:sp>
-      <p:sp>
-        <p:nvSpPr>
-          <p:cNvPr id="9" name="Text 7"/>
-          <p:cNvSpPr/>
-          <p:nvPr/>
-        </p:nvSpPr>
-        <p:spPr>
-          <a:xfrm>
-            <a:off x="457200" y="3291840"/>
-            <a:ext cx="6858000" cy="0"/>
-          </a:xfrm>
-          <a:prstGeom prst="rect">
-            <a:avLst/>
-          </a:prstGeom>
-          <a:noFill/>
-          <a:ln/>
-        </p:spPr>
-        <p:txBody>
-          <a:bodyPr wrap="square" rtlCol="0" anchor="ctr"/>
-          <a:lstStyle/>
-          <a:p>
-            <a:pPr indent="0" marL="0">
-              <a:buNone/>
-            </a:pPr>
-            <a:r>
-              <a:rPr lang="en-US" sz="1400" b="1" dirty="0">
-                <a:solidFill>
-                  <a:srgbClr val="10B981"/>
-                </a:solidFill>
-              </a:rPr>
-              <a:t>RAISE</a:t>
+              <a:t>A post-hardware "Mobility-as-a-Service" paradigm under the Beyond Zero initiative, deeply integrating physical cars with interconnected smart city grids and the globally synchronized "Digital Obeya" management cloud.</a:t>
             </a:r>
             <a:endParaRPr lang="en-US" sz="1400" dirty="0"/>
-          </a:p>
-        </p:txBody>
-      </p:sp>
-      <p:sp>
-        <p:nvSpPr>
-          <p:cNvPr id="10" name="Text 8"/>
-          <p:cNvSpPr/>
-          <p:nvPr/>
-        </p:nvSpPr>
-        <p:spPr>
-          <a:xfrm>
-            <a:off x="457200" y="3566160"/>
-            <a:ext cx="3657600" cy="0"/>
-          </a:xfrm>
-          <a:prstGeom prst="rect">
-            <a:avLst/>
-          </a:prstGeom>
-          <a:noFill/>
-          <a:ln/>
-        </p:spPr>
-        <p:txBody>
-          <a:bodyPr wrap="square" rtlCol="0" anchor="ctr"/>
-          <a:lstStyle/>
-          <a:p>
-            <a:pPr indent="0" marL="0">
-              <a:buNone/>
-            </a:pPr>
-            <a:r>
-              <a:rPr lang="en-US" sz="1200" dirty="0">
-                <a:solidFill>
-                  <a:srgbClr val="FFFFFF"/>
-                </a:solidFill>
-              </a:rPr>
-              <a:t>The global accessibility of electrified and sustainable mobility via affordable, highly durable HEV (hybrid) models across lower-to-middle income brackets practically everywhere.</a:t>
-            </a:r>
-            <a:endParaRPr lang="en-US" sz="1200" dirty="0"/>
-          </a:p>
-        </p:txBody>
-      </p:sp>
-      <p:sp>
-        <p:nvSpPr>
-          <p:cNvPr id="11" name="Text 9"/>
-          <p:cNvSpPr/>
-          <p:nvPr/>
-        </p:nvSpPr>
-        <p:spPr>
-          <a:xfrm>
-            <a:off x="4572000" y="3291840"/>
-            <a:ext cx="6858000" cy="0"/>
-          </a:xfrm>
-          <a:prstGeom prst="rect">
-            <a:avLst/>
-          </a:prstGeom>
-          <a:noFill/>
-          <a:ln/>
-        </p:spPr>
-        <p:txBody>
-          <a:bodyPr wrap="square" rtlCol="0" anchor="ctr"/>
-          <a:lstStyle/>
-          <a:p>
-            <a:pPr indent="0" marL="0">
-              <a:buNone/>
-            </a:pPr>
-            <a:r>
-              <a:rPr lang="en-US" sz="1400" b="1" dirty="0">
-                <a:solidFill>
-                  <a:srgbClr val="3B82F6"/>
-                </a:solidFill>
-              </a:rPr>
-              <a:t>CREATE</a:t>
-            </a:r>
-            <a:endParaRPr lang="en-US" sz="1400" dirty="0"/>
-          </a:p>
-        </p:txBody>
-      </p:sp>
-      <p:sp>
-        <p:nvSpPr>
-          <p:cNvPr id="12" name="Text 10"/>
-          <p:cNvSpPr/>
-          <p:nvPr/>
-        </p:nvSpPr>
-        <p:spPr>
-          <a:xfrm>
-            <a:off x="4572000" y="3566160"/>
-            <a:ext cx="3657600" cy="0"/>
-          </a:xfrm>
-          <a:prstGeom prst="rect">
-            <a:avLst/>
-          </a:prstGeom>
-          <a:noFill/>
-          <a:ln/>
-        </p:spPr>
-        <p:txBody>
-          <a:bodyPr wrap="square" rtlCol="0" anchor="ctr"/>
-          <a:lstStyle/>
-          <a:p>
-            <a:pPr indent="0" marL="0">
-              <a:buNone/>
-            </a:pPr>
-            <a:r>
-              <a:rPr lang="en-US" sz="1200" dirty="0">
-                <a:solidFill>
-                  <a:srgbClr val="FFFFFF"/>
-                </a:solidFill>
-              </a:rPr>
-              <a:t>A post-hardware "Mobility-as-a-Service" paradigm under the Beyond Zero initiative, deeply integrating physical cars with interconnected smart city grids and the globally synchronized "Digital Obeya" management cloud.</a:t>
-            </a:r>
-            <a:endParaRPr lang="en-US" sz="1200" dirty="0"/>
           </a:p>
         </p:txBody>
       </p:sp>
@@ -8749,8 +8392,8 @@
         </p:nvSpPr>
         <p:spPr>
           <a:xfrm>
-            <a:off x="457200" y="457200"/>
-            <a:ext cx="8229600" cy="0"/>
+            <a:off x="457200" y="365760"/>
+            <a:ext cx="8229600" cy="274320"/>
           </a:xfrm>
           <a:prstGeom prst="rect">
             <a:avLst/>
@@ -8759,7 +8402,7 @@
           <a:ln/>
         </p:spPr>
         <p:txBody>
-          <a:bodyPr wrap="square" rtlCol="0" anchor="ctr"/>
+          <a:bodyPr wrap="square" rtlCol="0" anchor="t"/>
           <a:lstStyle/>
           <a:p>
             <a:pPr indent="0" marL="0">
@@ -8785,8 +8428,8 @@
         </p:nvSpPr>
         <p:spPr>
           <a:xfrm>
-            <a:off x="457200" y="731520"/>
-            <a:ext cx="8229600" cy="0"/>
+            <a:off x="457200" y="640080"/>
+            <a:ext cx="8229600" cy="548640"/>
           </a:xfrm>
           <a:prstGeom prst="rect">
             <a:avLst/>
@@ -8795,21 +8438,21 @@
           <a:ln/>
         </p:spPr>
         <p:txBody>
-          <a:bodyPr wrap="square" rtlCol="0" anchor="ctr"/>
-          <a:lstStyle/>
-          <a:p>
-            <a:pPr indent="0" marL="0">
-              <a:buNone/>
-            </a:pPr>
-            <a:r>
-              <a:rPr lang="en-US" sz="2400" b="1" dirty="0">
+          <a:bodyPr wrap="square" rtlCol="0" anchor="t"/>
+          <a:lstStyle/>
+          <a:p>
+            <a:pPr indent="0" marL="0">
+              <a:buNone/>
+            </a:pPr>
+            <a:r>
+              <a:rPr lang="en-US" sz="2800" b="1" dirty="0">
                 <a:solidFill>
                   <a:srgbClr val="FFFFFF"/>
                 </a:solidFill>
               </a:rPr>
               <a:t>BCG matrix</a:t>
             </a:r>
-            <a:endParaRPr lang="en-US" sz="2400" dirty="0"/>
+            <a:endParaRPr lang="en-US" sz="2800" dirty="0"/>
           </a:p>
         </p:txBody>
       </p:sp>
@@ -8821,7 +8464,7 @@
         </p:nvSpPr>
         <p:spPr>
           <a:xfrm>
-            <a:off x="457200" y="1371600"/>
+            <a:off x="457200" y="1280160"/>
             <a:ext cx="8229600" cy="0"/>
           </a:xfrm>
           <a:prstGeom prst="line">
@@ -8844,8 +8487,8 @@
         </p:nvSpPr>
         <p:spPr>
           <a:xfrm>
-            <a:off x="457200" y="1645920"/>
-            <a:ext cx="6858000" cy="0"/>
+            <a:off x="457200" y="1463040"/>
+            <a:ext cx="3840480" cy="1463040"/>
           </a:xfrm>
           <a:prstGeom prst="rect">
             <a:avLst/>
@@ -8854,7 +8497,7 @@
           <a:ln/>
         </p:spPr>
         <p:txBody>
-          <a:bodyPr wrap="square" rtlCol="0" anchor="ctr"/>
+          <a:bodyPr wrap="square" rtlCol="0" anchor="t"/>
           <a:lstStyle/>
           <a:p>
             <a:pPr indent="0" marL="0">
@@ -8866,7 +8509,31 @@
                   <a:srgbClr val="3B82F6"/>
                 </a:solidFill>
               </a:rPr>
-              <a:t>STARS</a:t>
+              <a:t>STARS
+</a:t>
+            </a:r>
+            <a:pPr indent="0" marL="0">
+              <a:buNone/>
+            </a:pPr>
+            <a:r>
+              <a:rPr lang="en-US" sz="1200" b="1" dirty="0">
+                <a:solidFill>
+                  <a:srgbClr val="FFFFFF"/>
+                </a:solidFill>
+              </a:rPr>
+              <a:t>HEV (Hybrids) &amp; RAV4/Camry
+</a:t>
+            </a:r>
+            <a:pPr indent="0" marL="0">
+              <a:buNone/>
+            </a:pPr>
+            <a:r>
+              <a:rPr lang="en-US" sz="1200" dirty="0">
+                <a:solidFill>
+                  <a:srgbClr val="94A3B8"/>
+                </a:solidFill>
+              </a:rPr>
+              <a:t>High share, high growth. Current primary revenue drivers capturing transitional demand brilliantly.</a:t>
             </a:r>
             <a:endParaRPr lang="en-US" sz="1400" dirty="0"/>
           </a:p>
@@ -8880,8 +8547,8 @@
         </p:nvSpPr>
         <p:spPr>
           <a:xfrm>
-            <a:off x="457200" y="1920240"/>
-            <a:ext cx="3657600" cy="0"/>
+            <a:off x="4846320" y="1463040"/>
+            <a:ext cx="3840480" cy="1463040"/>
           </a:xfrm>
           <a:prstGeom prst="rect">
             <a:avLst/>
@@ -8890,293 +8557,165 @@
           <a:ln/>
         </p:spPr>
         <p:txBody>
-          <a:bodyPr wrap="square" rtlCol="0" anchor="ctr"/>
-          <a:lstStyle/>
-          <a:p>
+          <a:bodyPr wrap="square" rtlCol="0" anchor="t"/>
+          <a:lstStyle/>
+          <a:p>
+            <a:pPr indent="0" marL="0">
+              <a:buNone/>
+            </a:pPr>
+            <a:r>
+              <a:rPr lang="en-US" sz="1400" b="1" dirty="0">
+                <a:solidFill>
+                  <a:srgbClr val="A855F7"/>
+                </a:solidFill>
+              </a:rPr>
+              <a:t>QUESTION MARKS
+</a:t>
+            </a:r>
+            <a:pPr indent="0" marL="0">
+              <a:buNone/>
+            </a:pPr>
+            <a:r>
+              <a:rPr lang="en-US" sz="1200" b="1" dirty="0">
+                <a:solidFill>
+                  <a:srgbClr val="FFFFFF"/>
+                </a:solidFill>
+              </a:rPr>
+              <a:t>BEV (bZ4X) &amp; Hydrogen (Mirai)
+</a:t>
+            </a:r>
             <a:pPr indent="0" marL="0">
               <a:buNone/>
             </a:pPr>
             <a:r>
               <a:rPr lang="en-US" sz="1200" dirty="0">
                 <a:solidFill>
+                  <a:srgbClr val="94A3B8"/>
+                </a:solidFill>
+              </a:rPr>
+              <a:t>Low share, high growth. Require disproportionate, massive R&amp;D capital injections to secure a long-term future footing.</a:t>
+            </a:r>
+            <a:endParaRPr lang="en-US" sz="1400" dirty="0"/>
+          </a:p>
+        </p:txBody>
+      </p:sp>
+      <p:sp>
+        <p:nvSpPr>
+          <p:cNvPr id="7" name="Text 5"/>
+          <p:cNvSpPr/>
+          <p:nvPr/>
+        </p:nvSpPr>
+        <p:spPr>
+          <a:xfrm>
+            <a:off x="457200" y="3108960"/>
+            <a:ext cx="3840480" cy="1463040"/>
+          </a:xfrm>
+          <a:prstGeom prst="rect">
+            <a:avLst/>
+          </a:prstGeom>
+          <a:noFill/>
+          <a:ln/>
+        </p:spPr>
+        <p:txBody>
+          <a:bodyPr wrap="square" rtlCol="0" anchor="t"/>
+          <a:lstStyle/>
+          <a:p>
+            <a:pPr indent="0" marL="0">
+              <a:buNone/>
+            </a:pPr>
+            <a:r>
+              <a:rPr lang="en-US" sz="1400" b="1" dirty="0">
+                <a:solidFill>
+                  <a:srgbClr val="10B981"/>
+                </a:solidFill>
+              </a:rPr>
+              <a:t>CASH COWS
+</a:t>
+            </a:r>
+            <a:pPr indent="0" marL="0">
+              <a:buNone/>
+            </a:pPr>
+            <a:r>
+              <a:rPr lang="en-US" sz="1200" b="1" dirty="0">
+                <a:solidFill>
                   <a:srgbClr val="FFFFFF"/>
                 </a:solidFill>
               </a:rPr>
-              <a:t>HEV (Hybrids) &amp; RAV4/Camry</a:t>
-            </a:r>
-            <a:endParaRPr lang="en-US" sz="1200" dirty="0"/>
-          </a:p>
-          <a:p>
+              <a:t>ICE Trucks &amp; SUVs (Tacoma)
+</a:t>
+            </a:r>
             <a:pPr indent="0" marL="0">
               <a:buNone/>
             </a:pPr>
             <a:r>
               <a:rPr lang="en-US" sz="1200" dirty="0">
                 <a:solidFill>
+                  <a:srgbClr val="94A3B8"/>
+                </a:solidFill>
+              </a:rPr>
+              <a:t>High share, low growth. Highly profitable legacy models that generate immense free cash flow to fund R&amp;D electrification.</a:t>
+            </a:r>
+            <a:endParaRPr lang="en-US" sz="1400" dirty="0"/>
+          </a:p>
+        </p:txBody>
+      </p:sp>
+      <p:sp>
+        <p:nvSpPr>
+          <p:cNvPr id="8" name="Text 6"/>
+          <p:cNvSpPr/>
+          <p:nvPr/>
+        </p:nvSpPr>
+        <p:spPr>
+          <a:xfrm>
+            <a:off x="4846320" y="3108960"/>
+            <a:ext cx="3840480" cy="1463040"/>
+          </a:xfrm>
+          <a:prstGeom prst="rect">
+            <a:avLst/>
+          </a:prstGeom>
+          <a:noFill/>
+          <a:ln/>
+        </p:spPr>
+        <p:txBody>
+          <a:bodyPr wrap="square" rtlCol="0" anchor="t"/>
+          <a:lstStyle/>
+          <a:p>
+            <a:pPr indent="0" marL="0">
+              <a:buNone/>
+            </a:pPr>
+            <a:r>
+              <a:rPr lang="en-US" sz="1400" b="1" dirty="0">
+                <a:solidFill>
+                  <a:srgbClr val="94A3B8"/>
+                </a:solidFill>
+              </a:rPr>
+              <a:t>DOGS
+</a:t>
+            </a:r>
+            <a:pPr indent="0" marL="0">
+              <a:buNone/>
+            </a:pPr>
+            <a:r>
+              <a:rPr lang="en-US" sz="1200" b="1" dirty="0">
+                <a:solidFill>
                   <a:srgbClr val="FFFFFF"/>
                 </a:solidFill>
               </a:rPr>
-              <a:t>High share, high growth. Current primary revenue drivers capturing transitional demand brilliantly.</a:t>
-            </a:r>
-            <a:endParaRPr lang="en-US" sz="1200" dirty="0"/>
-          </a:p>
-        </p:txBody>
-      </p:sp>
-      <p:sp>
-        <p:nvSpPr>
-          <p:cNvPr id="7" name="Text 5"/>
-          <p:cNvSpPr/>
-          <p:nvPr/>
-        </p:nvSpPr>
-        <p:spPr>
-          <a:xfrm>
-            <a:off x="4572000" y="1645920"/>
-            <a:ext cx="6858000" cy="0"/>
-          </a:xfrm>
-          <a:prstGeom prst="rect">
-            <a:avLst/>
-          </a:prstGeom>
-          <a:noFill/>
-          <a:ln/>
-        </p:spPr>
-        <p:txBody>
-          <a:bodyPr wrap="square" rtlCol="0" anchor="ctr"/>
-          <a:lstStyle/>
-          <a:p>
-            <a:pPr indent="0" marL="0">
-              <a:buNone/>
-            </a:pPr>
-            <a:r>
-              <a:rPr lang="en-US" sz="1400" b="1" dirty="0">
-                <a:solidFill>
-                  <a:srgbClr val="A855F7"/>
-                </a:solidFill>
-              </a:rPr>
-              <a:t>QUESTION MARKS</a:t>
+              <a:t>Compact &amp; Midsize ICE Sedans
+</a:t>
+            </a:r>
+            <a:pPr indent="0" marL="0">
+              <a:buNone/>
+            </a:pPr>
+            <a:r>
+              <a:rPr lang="en-US" sz="1200" dirty="0">
+                <a:solidFill>
+                  <a:srgbClr val="94A3B8"/>
+                </a:solidFill>
+              </a:rPr>
+              <a:t>Low share, low growth. Toyota is rapidly consolidating away from traditional sedan segments to prevent capital drift as consumers favor SUVs.</a:t>
             </a:r>
             <a:endParaRPr lang="en-US" sz="1400" dirty="0"/>
-          </a:p>
-        </p:txBody>
-      </p:sp>
-      <p:sp>
-        <p:nvSpPr>
-          <p:cNvPr id="8" name="Text 6"/>
-          <p:cNvSpPr/>
-          <p:nvPr/>
-        </p:nvSpPr>
-        <p:spPr>
-          <a:xfrm>
-            <a:off x="4572000" y="1920240"/>
-            <a:ext cx="3657600" cy="0"/>
-          </a:xfrm>
-          <a:prstGeom prst="rect">
-            <a:avLst/>
-          </a:prstGeom>
-          <a:noFill/>
-          <a:ln/>
-        </p:spPr>
-        <p:txBody>
-          <a:bodyPr wrap="square" rtlCol="0" anchor="ctr"/>
-          <a:lstStyle/>
-          <a:p>
-            <a:pPr indent="0" marL="0">
-              <a:buNone/>
-            </a:pPr>
-            <a:r>
-              <a:rPr lang="en-US" sz="1200" dirty="0">
-                <a:solidFill>
-                  <a:srgbClr val="FFFFFF"/>
-                </a:solidFill>
-              </a:rPr>
-              <a:t>BEV (bZ4X) &amp; Hydrogen (Mirai)</a:t>
-            </a:r>
-            <a:endParaRPr lang="en-US" sz="1200" dirty="0"/>
-          </a:p>
-          <a:p>
-            <a:pPr indent="0" marL="0">
-              <a:buNone/>
-            </a:pPr>
-            <a:r>
-              <a:rPr lang="en-US" sz="1200" dirty="0">
-                <a:solidFill>
-                  <a:srgbClr val="FFFFFF"/>
-                </a:solidFill>
-              </a:rPr>
-              <a:t>Low share, high growth. Require disproportionate, massive R&amp;D capital injections to secure a long-term future footing.</a:t>
-            </a:r>
-            <a:endParaRPr lang="en-US" sz="1200" dirty="0"/>
-          </a:p>
-        </p:txBody>
-      </p:sp>
-      <p:sp>
-        <p:nvSpPr>
-          <p:cNvPr id="9" name="Text 7"/>
-          <p:cNvSpPr/>
-          <p:nvPr/>
-        </p:nvSpPr>
-        <p:spPr>
-          <a:xfrm>
-            <a:off x="457200" y="3291840"/>
-            <a:ext cx="6858000" cy="0"/>
-          </a:xfrm>
-          <a:prstGeom prst="rect">
-            <a:avLst/>
-          </a:prstGeom>
-          <a:noFill/>
-          <a:ln/>
-        </p:spPr>
-        <p:txBody>
-          <a:bodyPr wrap="square" rtlCol="0" anchor="ctr"/>
-          <a:lstStyle/>
-          <a:p>
-            <a:pPr indent="0" marL="0">
-              <a:buNone/>
-            </a:pPr>
-            <a:r>
-              <a:rPr lang="en-US" sz="1400" b="1" dirty="0">
-                <a:solidFill>
-                  <a:srgbClr val="10B981"/>
-                </a:solidFill>
-              </a:rPr>
-              <a:t>CASH COWS</a:t>
-            </a:r>
-            <a:endParaRPr lang="en-US" sz="1400" dirty="0"/>
-          </a:p>
-        </p:txBody>
-      </p:sp>
-      <p:sp>
-        <p:nvSpPr>
-          <p:cNvPr id="10" name="Text 8"/>
-          <p:cNvSpPr/>
-          <p:nvPr/>
-        </p:nvSpPr>
-        <p:spPr>
-          <a:xfrm>
-            <a:off x="457200" y="3566160"/>
-            <a:ext cx="3657600" cy="0"/>
-          </a:xfrm>
-          <a:prstGeom prst="rect">
-            <a:avLst/>
-          </a:prstGeom>
-          <a:noFill/>
-          <a:ln/>
-        </p:spPr>
-        <p:txBody>
-          <a:bodyPr wrap="square" rtlCol="0" anchor="ctr"/>
-          <a:lstStyle/>
-          <a:p>
-            <a:pPr indent="0" marL="0">
-              <a:buNone/>
-            </a:pPr>
-            <a:r>
-              <a:rPr lang="en-US" sz="1200" dirty="0">
-                <a:solidFill>
-                  <a:srgbClr val="FFFFFF"/>
-                </a:solidFill>
-              </a:rPr>
-              <a:t>ICE Trucks &amp; SUVs (Tacoma)</a:t>
-            </a:r>
-            <a:endParaRPr lang="en-US" sz="1200" dirty="0"/>
-          </a:p>
-          <a:p>
-            <a:pPr indent="0" marL="0">
-              <a:buNone/>
-            </a:pPr>
-            <a:r>
-              <a:rPr lang="en-US" sz="1200" dirty="0">
-                <a:solidFill>
-                  <a:srgbClr val="FFFFFF"/>
-                </a:solidFill>
-              </a:rPr>
-              <a:t>High share, low growth. Highly profitable legacy models that generate immense free cash flow to fund R&amp;D electrification.</a:t>
-            </a:r>
-            <a:endParaRPr lang="en-US" sz="1200" dirty="0"/>
-          </a:p>
-        </p:txBody>
-      </p:sp>
-      <p:sp>
-        <p:nvSpPr>
-          <p:cNvPr id="11" name="Text 9"/>
-          <p:cNvSpPr/>
-          <p:nvPr/>
-        </p:nvSpPr>
-        <p:spPr>
-          <a:xfrm>
-            <a:off x="4572000" y="3291840"/>
-            <a:ext cx="6858000" cy="0"/>
-          </a:xfrm>
-          <a:prstGeom prst="rect">
-            <a:avLst/>
-          </a:prstGeom>
-          <a:noFill/>
-          <a:ln/>
-        </p:spPr>
-        <p:txBody>
-          <a:bodyPr wrap="square" rtlCol="0" anchor="ctr"/>
-          <a:lstStyle/>
-          <a:p>
-            <a:pPr indent="0" marL="0">
-              <a:buNone/>
-            </a:pPr>
-            <a:r>
-              <a:rPr lang="en-US" sz="1400" b="1" dirty="0">
-                <a:solidFill>
-                  <a:srgbClr val="94A3B8"/>
-                </a:solidFill>
-              </a:rPr>
-              <a:t>DOGS</a:t>
-            </a:r>
-            <a:endParaRPr lang="en-US" sz="1400" dirty="0"/>
-          </a:p>
-        </p:txBody>
-      </p:sp>
-      <p:sp>
-        <p:nvSpPr>
-          <p:cNvPr id="12" name="Text 10"/>
-          <p:cNvSpPr/>
-          <p:nvPr/>
-        </p:nvSpPr>
-        <p:spPr>
-          <a:xfrm>
-            <a:off x="4572000" y="3566160"/>
-            <a:ext cx="3657600" cy="0"/>
-          </a:xfrm>
-          <a:prstGeom prst="rect">
-            <a:avLst/>
-          </a:prstGeom>
-          <a:noFill/>
-          <a:ln/>
-        </p:spPr>
-        <p:txBody>
-          <a:bodyPr wrap="square" rtlCol="0" anchor="ctr"/>
-          <a:lstStyle/>
-          <a:p>
-            <a:pPr indent="0" marL="0">
-              <a:buNone/>
-            </a:pPr>
-            <a:r>
-              <a:rPr lang="en-US" sz="1200" dirty="0">
-                <a:solidFill>
-                  <a:srgbClr val="FFFFFF"/>
-                </a:solidFill>
-              </a:rPr>
-              <a:t>Compact &amp; Midsize ICE Sedans</a:t>
-            </a:r>
-            <a:endParaRPr lang="en-US" sz="1200" dirty="0"/>
-          </a:p>
-          <a:p>
-            <a:pPr indent="0" marL="0">
-              <a:buNone/>
-            </a:pPr>
-            <a:r>
-              <a:rPr lang="en-US" sz="1200" dirty="0">
-                <a:solidFill>
-                  <a:srgbClr val="FFFFFF"/>
-                </a:solidFill>
-              </a:rPr>
-              <a:t>Low share, low growth. Toyota is rapidly consolidating away from traditional sedan segments to prevent capital drift as consumers favor SUVs.</a:t>
-            </a:r>
-            <a:endParaRPr lang="en-US" sz="1200" dirty="0"/>
           </a:p>
         </p:txBody>
       </p:sp>
@@ -9258,8 +8797,8 @@
         </p:nvSpPr>
         <p:spPr>
           <a:xfrm>
-            <a:off x="457200" y="457200"/>
-            <a:ext cx="8229600" cy="0"/>
+            <a:off x="457200" y="365760"/>
+            <a:ext cx="8229600" cy="274320"/>
           </a:xfrm>
           <a:prstGeom prst="rect">
             <a:avLst/>
@@ -9268,7 +8807,7 @@
           <a:ln/>
         </p:spPr>
         <p:txBody>
-          <a:bodyPr wrap="square" rtlCol="0" anchor="ctr"/>
+          <a:bodyPr wrap="square" rtlCol="0" anchor="t"/>
           <a:lstStyle/>
           <a:p>
             <a:pPr indent="0" marL="0">
@@ -9294,8 +8833,8 @@
         </p:nvSpPr>
         <p:spPr>
           <a:xfrm>
-            <a:off x="457200" y="731520"/>
-            <a:ext cx="8229600" cy="0"/>
+            <a:off x="457200" y="640080"/>
+            <a:ext cx="8229600" cy="548640"/>
           </a:xfrm>
           <a:prstGeom prst="rect">
             <a:avLst/>
@@ -9304,21 +8843,21 @@
           <a:ln/>
         </p:spPr>
         <p:txBody>
-          <a:bodyPr wrap="square" rtlCol="0" anchor="ctr"/>
-          <a:lstStyle/>
-          <a:p>
-            <a:pPr indent="0" marL="0">
-              <a:buNone/>
-            </a:pPr>
-            <a:r>
-              <a:rPr lang="en-US" sz="2400" b="1" dirty="0">
+          <a:bodyPr wrap="square" rtlCol="0" anchor="t"/>
+          <a:lstStyle/>
+          <a:p>
+            <a:pPr indent="0" marL="0">
+              <a:buNone/>
+            </a:pPr>
+            <a:r>
+              <a:rPr lang="en-US" sz="2800" b="1" dirty="0">
                 <a:solidFill>
                   <a:srgbClr val="FFFFFF"/>
                 </a:solidFill>
               </a:rPr>
               <a:t>Porter's five forces</a:t>
             </a:r>
-            <a:endParaRPr lang="en-US" sz="2400" dirty="0"/>
+            <a:endParaRPr lang="en-US" sz="2800" dirty="0"/>
           </a:p>
         </p:txBody>
       </p:sp>
@@ -9330,7 +8869,7 @@
         </p:nvSpPr>
         <p:spPr>
           <a:xfrm>
-            <a:off x="457200" y="1371600"/>
+            <a:off x="457200" y="1280160"/>
             <a:ext cx="8229600" cy="0"/>
           </a:xfrm>
           <a:prstGeom prst="line">
@@ -9353,8 +8892,8 @@
         </p:nvSpPr>
         <p:spPr>
           <a:xfrm>
-            <a:off x="457200" y="1645920"/>
-            <a:ext cx="6858000" cy="0"/>
+            <a:off x="457200" y="1463040"/>
+            <a:ext cx="2560320" cy="1645920"/>
           </a:xfrm>
           <a:prstGeom prst="rect">
             <a:avLst/>
@@ -9363,21 +8902,44 @@
           <a:ln/>
         </p:spPr>
         <p:txBody>
-          <a:bodyPr wrap="square" rtlCol="0" anchor="ctr"/>
-          <a:lstStyle/>
-          <a:p>
-            <a:pPr indent="0" marL="0">
-              <a:buNone/>
-            </a:pPr>
-            <a:r>
-              <a:rPr lang="en-US" sz="1400" b="1" dirty="0">
+          <a:bodyPr wrap="square" rtlCol="0" anchor="t"/>
+          <a:lstStyle/>
+          <a:p>
+            <a:pPr indent="0" marL="0">
+              <a:buNone/>
+            </a:pPr>
+            <a:r>
+              <a:rPr lang="en-US" b="1" dirty="0">
+                <a:solidFill>
+                  <a:srgbClr val="FFFFFF"/>
+                </a:solidFill>
+              </a:rPr>
+              <a:t>Rivalry </a:t>
+            </a:r>
+            <a:pPr indent="0" marL="0">
+              <a:buNone/>
+            </a:pPr>
+            <a:r>
+              <a:rPr lang="en-US" b="1" dirty="0">
                 <a:solidFill>
                   <a:srgbClr val="EF4444"/>
                 </a:solidFill>
               </a:rPr>
-              <a:t>Rivalry (Very High)</a:t>
-            </a:r>
-            <a:endParaRPr lang="en-US" sz="1400" dirty="0"/>
+              <a:t>(Very High)
+</a:t>
+            </a:r>
+            <a:pPr indent="0" marL="0">
+              <a:buNone/>
+            </a:pPr>
+            <a:r>
+              <a:rPr lang="en-US" sz="1200" dirty="0">
+                <a:solidFill>
+                  <a:srgbClr val="94A3B8"/>
+                </a:solidFill>
+              </a:rPr>
+              <a:t>Direct brutal confrontation with VW, Hyundai, and subsidized Chinese EV OEMs causing severe margin compression.</a:t>
+            </a:r>
+            <a:endParaRPr lang="en-US" sz="1200" dirty="0"/>
           </a:p>
         </p:txBody>
       </p:sp>
@@ -9389,8 +8951,8 @@
         </p:nvSpPr>
         <p:spPr>
           <a:xfrm>
-            <a:off x="457200" y="1920240"/>
-            <a:ext cx="2286000" cy="0"/>
+            <a:off x="3291840" y="1463040"/>
+            <a:ext cx="2560320" cy="1645920"/>
           </a:xfrm>
           <a:prstGeom prst="rect">
             <a:avLst/>
@@ -9399,19 +8961,101 @@
           <a:ln/>
         </p:spPr>
         <p:txBody>
-          <a:bodyPr wrap="square" rtlCol="0" anchor="ctr"/>
-          <a:lstStyle/>
-          <a:p>
+          <a:bodyPr wrap="square" rtlCol="0" anchor="t"/>
+          <a:lstStyle/>
+          <a:p>
+            <a:pPr indent="0" marL="0">
+              <a:buNone/>
+            </a:pPr>
+            <a:r>
+              <a:rPr lang="en-US" b="1" dirty="0">
+                <a:solidFill>
+                  <a:srgbClr val="FFFFFF"/>
+                </a:solidFill>
+              </a:rPr>
+              <a:t>Buyers </a:t>
+            </a:r>
+            <a:pPr indent="0" marL="0">
+              <a:buNone/>
+            </a:pPr>
+            <a:r>
+              <a:rPr lang="en-US" b="1" dirty="0">
+                <a:solidFill>
+                  <a:srgbClr val="F97316"/>
+                </a:solidFill>
+              </a:rPr>
+              <a:t>(Mod-High)
+</a:t>
+            </a:r>
             <a:pPr indent="0" marL="0">
               <a:buNone/>
             </a:pPr>
             <a:r>
               <a:rPr lang="en-US" sz="1200" dirty="0">
                 <a:solidFill>
+                  <a:srgbClr val="94A3B8"/>
+                </a:solidFill>
+              </a:rPr>
+              <a:t>Armed with digital pricing transparency; loss of tax credits amplifies intense price sensitivity for EVs.</a:t>
+            </a:r>
+            <a:endParaRPr lang="en-US" sz="1200" dirty="0"/>
+          </a:p>
+        </p:txBody>
+      </p:sp>
+      <p:sp>
+        <p:nvSpPr>
+          <p:cNvPr id="7" name="Text 5"/>
+          <p:cNvSpPr/>
+          <p:nvPr/>
+        </p:nvSpPr>
+        <p:spPr>
+          <a:xfrm>
+            <a:off x="6126480" y="1463040"/>
+            <a:ext cx="2560320" cy="1645920"/>
+          </a:xfrm>
+          <a:prstGeom prst="rect">
+            <a:avLst/>
+          </a:prstGeom>
+          <a:noFill/>
+          <a:ln/>
+        </p:spPr>
+        <p:txBody>
+          <a:bodyPr wrap="square" rtlCol="0" anchor="t"/>
+          <a:lstStyle/>
+          <a:p>
+            <a:pPr indent="0" marL="0">
+              <a:buNone/>
+            </a:pPr>
+            <a:r>
+              <a:rPr lang="en-US" b="1" dirty="0">
+                <a:solidFill>
                   <a:srgbClr val="FFFFFF"/>
                 </a:solidFill>
               </a:rPr>
-              <a:t>Direct brutal confrontation with VW, Hyundai, and subsidized Chinese EV OEMs causing severe margin compression.</a:t>
+              <a:t>Suppliers </a:t>
+            </a:r>
+            <a:pPr indent="0" marL="0">
+              <a:buNone/>
+            </a:pPr>
+            <a:r>
+              <a:rPr lang="en-US" b="1" dirty="0">
+                <a:solidFill>
+                  <a:srgbClr val="F97316"/>
+                </a:solidFill>
+              </a:rPr>
+              <a:t>(Mod-High)
+</a:t>
+            </a:r>
+            <a:pPr indent="0" marL="0">
+              <a:buNone/>
+            </a:pPr>
+            <a:r>
+              <a:rPr lang="en-US" sz="1200" dirty="0">
+                <a:solidFill>
+                  <a:srgbClr val="94A3B8"/>
+                </a:solidFill>
+              </a:rPr>
+              <a:t>Extortion leverage via rare-earth minerals countered by massive $13.9B vertical integration.</a:t>
             </a:r>
             <a:endParaRPr lang="en-US" sz="1200" dirty="0"/>
           </a:p>
@@ -9419,14 +9063,14 @@
       </p:sp>
       <p:sp>
         <p:nvSpPr>
-          <p:cNvPr id="7" name="Text 5"/>
-          <p:cNvSpPr/>
-          <p:nvPr/>
-        </p:nvSpPr>
-        <p:spPr>
-          <a:xfrm>
-            <a:off x="3200400" y="1645920"/>
-            <a:ext cx="6858000" cy="0"/>
+          <p:cNvPr id="8" name="Text 6"/>
+          <p:cNvSpPr/>
+          <p:nvPr/>
+        </p:nvSpPr>
+        <p:spPr>
+          <a:xfrm>
+            <a:off x="1371600" y="3291840"/>
+            <a:ext cx="2926080" cy="1463040"/>
           </a:xfrm>
           <a:prstGeom prst="rect">
             <a:avLst/>
@@ -9435,34 +9079,57 @@
           <a:ln/>
         </p:spPr>
         <p:txBody>
-          <a:bodyPr wrap="square" rtlCol="0" anchor="ctr"/>
-          <a:lstStyle/>
-          <a:p>
-            <a:pPr indent="0" marL="0">
-              <a:buNone/>
-            </a:pPr>
-            <a:r>
-              <a:rPr lang="en-US" sz="1400" b="1" dirty="0">
-                <a:solidFill>
-                  <a:srgbClr val="F97316"/>
-                </a:solidFill>
-              </a:rPr>
-              <a:t>Buyers (Mod-High)</a:t>
-            </a:r>
-            <a:endParaRPr lang="en-US" sz="1400" dirty="0"/>
-          </a:p>
-        </p:txBody>
-      </p:sp>
-      <p:sp>
-        <p:nvSpPr>
-          <p:cNvPr id="8" name="Text 6"/>
-          <p:cNvSpPr/>
-          <p:nvPr/>
-        </p:nvSpPr>
-        <p:spPr>
-          <a:xfrm>
-            <a:off x="3200400" y="1920240"/>
-            <a:ext cx="2286000" cy="0"/>
+          <a:bodyPr wrap="square" rtlCol="0" anchor="t"/>
+          <a:lstStyle/>
+          <a:p>
+            <a:pPr indent="0" marL="0">
+              <a:buNone/>
+            </a:pPr>
+            <a:r>
+              <a:rPr lang="en-US" b="1" dirty="0">
+                <a:solidFill>
+                  <a:srgbClr val="FFFFFF"/>
+                </a:solidFill>
+              </a:rPr>
+              <a:t>New entrants </a:t>
+            </a:r>
+            <a:pPr indent="0" marL="0">
+              <a:buNone/>
+            </a:pPr>
+            <a:r>
+              <a:rPr lang="en-US" b="1" dirty="0">
+                <a:solidFill>
+                  <a:srgbClr val="EAB308"/>
+                </a:solidFill>
+              </a:rPr>
+              <a:t>(Moderate)
+</a:t>
+            </a:r>
+            <a:pPr indent="0" marL="0">
+              <a:buNone/>
+            </a:pPr>
+            <a:r>
+              <a:rPr lang="en-US" sz="1200" dirty="0">
+                <a:solidFill>
+                  <a:srgbClr val="94A3B8"/>
+                </a:solidFill>
+              </a:rPr>
+              <a:t>Software-first entrants bypass legacy manufacturing barriers.</a:t>
+            </a:r>
+            <a:endParaRPr lang="en-US" sz="1200" dirty="0"/>
+          </a:p>
+        </p:txBody>
+      </p:sp>
+      <p:sp>
+        <p:nvSpPr>
+          <p:cNvPr id="9" name="Text 7"/>
+          <p:cNvSpPr/>
+          <p:nvPr/>
+        </p:nvSpPr>
+        <p:spPr>
+          <a:xfrm>
+            <a:off x="4846320" y="3291840"/>
+            <a:ext cx="2926080" cy="1463040"/>
           </a:xfrm>
           <a:prstGeom prst="rect">
             <a:avLst/>
@@ -9471,232 +9138,39 @@
           <a:ln/>
         </p:spPr>
         <p:txBody>
-          <a:bodyPr wrap="square" rtlCol="0" anchor="ctr"/>
-          <a:lstStyle/>
-          <a:p>
+          <a:bodyPr wrap="square" rtlCol="0" anchor="t"/>
+          <a:lstStyle/>
+          <a:p>
+            <a:pPr indent="0" marL="0">
+              <a:buNone/>
+            </a:pPr>
+            <a:r>
+              <a:rPr lang="en-US" b="1" dirty="0">
+                <a:solidFill>
+                  <a:srgbClr val="FFFFFF"/>
+                </a:solidFill>
+              </a:rPr>
+              <a:t>Substitutes </a:t>
+            </a:r>
+            <a:pPr indent="0" marL="0">
+              <a:buNone/>
+            </a:pPr>
+            <a:r>
+              <a:rPr lang="en-US" b="1" dirty="0">
+                <a:solidFill>
+                  <a:srgbClr val="EAB308"/>
+                </a:solidFill>
+              </a:rPr>
+              <a:t>(Moderate)
+</a:t>
+            </a:r>
             <a:pPr indent="0" marL="0">
               <a:buNone/>
             </a:pPr>
             <a:r>
               <a:rPr lang="en-US" sz="1200" dirty="0">
                 <a:solidFill>
-                  <a:srgbClr val="FFFFFF"/>
-                </a:solidFill>
-              </a:rPr>
-              <a:t>Armed with digital pricing transparency; loss of tax credits amplifies intense price sensitivity for EVs.</a:t>
-            </a:r>
-            <a:endParaRPr lang="en-US" sz="1200" dirty="0"/>
-          </a:p>
-        </p:txBody>
-      </p:sp>
-      <p:sp>
-        <p:nvSpPr>
-          <p:cNvPr id="9" name="Text 7"/>
-          <p:cNvSpPr/>
-          <p:nvPr/>
-        </p:nvSpPr>
-        <p:spPr>
-          <a:xfrm>
-            <a:off x="5943600" y="1645920"/>
-            <a:ext cx="6858000" cy="0"/>
-          </a:xfrm>
-          <a:prstGeom prst="rect">
-            <a:avLst/>
-          </a:prstGeom>
-          <a:noFill/>
-          <a:ln/>
-        </p:spPr>
-        <p:txBody>
-          <a:bodyPr wrap="square" rtlCol="0" anchor="ctr"/>
-          <a:lstStyle/>
-          <a:p>
-            <a:pPr indent="0" marL="0">
-              <a:buNone/>
-            </a:pPr>
-            <a:r>
-              <a:rPr lang="en-US" sz="1400" b="1" dirty="0">
-                <a:solidFill>
-                  <a:srgbClr val="F97316"/>
-                </a:solidFill>
-              </a:rPr>
-              <a:t>Suppliers (Mod-High)</a:t>
-            </a:r>
-            <a:endParaRPr lang="en-US" sz="1400" dirty="0"/>
-          </a:p>
-        </p:txBody>
-      </p:sp>
-      <p:sp>
-        <p:nvSpPr>
-          <p:cNvPr id="10" name="Text 8"/>
-          <p:cNvSpPr/>
-          <p:nvPr/>
-        </p:nvSpPr>
-        <p:spPr>
-          <a:xfrm>
-            <a:off x="5943600" y="1920240"/>
-            <a:ext cx="2286000" cy="0"/>
-          </a:xfrm>
-          <a:prstGeom prst="rect">
-            <a:avLst/>
-          </a:prstGeom>
-          <a:noFill/>
-          <a:ln/>
-        </p:spPr>
-        <p:txBody>
-          <a:bodyPr wrap="square" rtlCol="0" anchor="ctr"/>
-          <a:lstStyle/>
-          <a:p>
-            <a:pPr indent="0" marL="0">
-              <a:buNone/>
-            </a:pPr>
-            <a:r>
-              <a:rPr lang="en-US" sz="1200" dirty="0">
-                <a:solidFill>
-                  <a:srgbClr val="FFFFFF"/>
-                </a:solidFill>
-              </a:rPr>
-              <a:t>Extortion leverage via rare-earth minerals countered by massive $13.9B vertical integration.</a:t>
-            </a:r>
-            <a:endParaRPr lang="en-US" sz="1200" dirty="0"/>
-          </a:p>
-        </p:txBody>
-      </p:sp>
-      <p:sp>
-        <p:nvSpPr>
-          <p:cNvPr id="11" name="Text 9"/>
-          <p:cNvSpPr/>
-          <p:nvPr/>
-        </p:nvSpPr>
-        <p:spPr>
-          <a:xfrm>
-            <a:off x="1371600" y="3200400"/>
-            <a:ext cx="6858000" cy="0"/>
-          </a:xfrm>
-          <a:prstGeom prst="rect">
-            <a:avLst/>
-          </a:prstGeom>
-          <a:noFill/>
-          <a:ln/>
-        </p:spPr>
-        <p:txBody>
-          <a:bodyPr wrap="square" rtlCol="0" anchor="ctr"/>
-          <a:lstStyle/>
-          <a:p>
-            <a:pPr indent="0" marL="0">
-              <a:buNone/>
-            </a:pPr>
-            <a:r>
-              <a:rPr lang="en-US" sz="1400" b="1" dirty="0">
-                <a:solidFill>
-                  <a:srgbClr val="EAB308"/>
-                </a:solidFill>
-              </a:rPr>
-              <a:t>New entrants (Moderate)</a:t>
-            </a:r>
-            <a:endParaRPr lang="en-US" sz="1400" dirty="0"/>
-          </a:p>
-        </p:txBody>
-      </p:sp>
-      <p:sp>
-        <p:nvSpPr>
-          <p:cNvPr id="12" name="Text 10"/>
-          <p:cNvSpPr/>
-          <p:nvPr/>
-        </p:nvSpPr>
-        <p:spPr>
-          <a:xfrm>
-            <a:off x="1371600" y="3474720"/>
-            <a:ext cx="2743200" cy="0"/>
-          </a:xfrm>
-          <a:prstGeom prst="rect">
-            <a:avLst/>
-          </a:prstGeom>
-          <a:noFill/>
-          <a:ln/>
-        </p:spPr>
-        <p:txBody>
-          <a:bodyPr wrap="square" rtlCol="0" anchor="ctr"/>
-          <a:lstStyle/>
-          <a:p>
-            <a:pPr indent="0" marL="0">
-              <a:buNone/>
-            </a:pPr>
-            <a:r>
-              <a:rPr lang="en-US" sz="1200" dirty="0">
-                <a:solidFill>
-                  <a:srgbClr val="FFFFFF"/>
-                </a:solidFill>
-              </a:rPr>
-              <a:t>Software-first entrants bypass legacy manufacturing barriers.</a:t>
-            </a:r>
-            <a:endParaRPr lang="en-US" sz="1200" dirty="0"/>
-          </a:p>
-        </p:txBody>
-      </p:sp>
-      <p:sp>
-        <p:nvSpPr>
-          <p:cNvPr id="13" name="Text 11"/>
-          <p:cNvSpPr/>
-          <p:nvPr/>
-        </p:nvSpPr>
-        <p:spPr>
-          <a:xfrm>
-            <a:off x="4572000" y="3200400"/>
-            <a:ext cx="6858000" cy="0"/>
-          </a:xfrm>
-          <a:prstGeom prst="rect">
-            <a:avLst/>
-          </a:prstGeom>
-          <a:noFill/>
-          <a:ln/>
-        </p:spPr>
-        <p:txBody>
-          <a:bodyPr wrap="square" rtlCol="0" anchor="ctr"/>
-          <a:lstStyle/>
-          <a:p>
-            <a:pPr indent="0" marL="0">
-              <a:buNone/>
-            </a:pPr>
-            <a:r>
-              <a:rPr lang="en-US" sz="1400" b="1" dirty="0">
-                <a:solidFill>
-                  <a:srgbClr val="EAB308"/>
-                </a:solidFill>
-              </a:rPr>
-              <a:t>Substitutes (Moderate)</a:t>
-            </a:r>
-            <a:endParaRPr lang="en-US" sz="1400" dirty="0"/>
-          </a:p>
-        </p:txBody>
-      </p:sp>
-      <p:sp>
-        <p:nvSpPr>
-          <p:cNvPr id="14" name="Text 12"/>
-          <p:cNvSpPr/>
-          <p:nvPr/>
-        </p:nvSpPr>
-        <p:spPr>
-          <a:xfrm>
-            <a:off x="4572000" y="3474720"/>
-            <a:ext cx="3657600" cy="0"/>
-          </a:xfrm>
-          <a:prstGeom prst="rect">
-            <a:avLst/>
-          </a:prstGeom>
-          <a:noFill/>
-          <a:ln/>
-        </p:spPr>
-        <p:txBody>
-          <a:bodyPr wrap="square" rtlCol="0" anchor="ctr"/>
-          <a:lstStyle/>
-          <a:p>
-            <a:pPr indent="0" marL="0">
-              <a:buNone/>
-            </a:pPr>
-            <a:r>
-              <a:rPr lang="en-US" sz="1200" dirty="0">
-                <a:solidFill>
-                  <a:srgbClr val="FFFFFF"/>
+                  <a:srgbClr val="94A3B8"/>
                 </a:solidFill>
               </a:rPr>
               <a:t>Urban mobility platforms (Uber) and high-speed rail hedge exactly why Toyota is becoming a broad "mobility" provider.</a:t>

</xml_diff>